<commit_message>
Use Georgia headlines with Arial body on the bento slide
Classic editorial serif for titles and tile headlines; both fonts ship
with PowerPoint, so the deck renders the same on any machine.

Co-Authored-By: Claude Opus 5.5 <noreply@anthropic.com>
Claude-Session: https://claude.ai/code/session_01XfzJZGxwThMkoxLN562VyL
</commit_message>
<xml_diff>
--- a/india-today-ai-slides/Option_C_AI_at_India_Today_Bento.pptx
+++ b/india-today-ai-slides/Option_C_AI_at_India_Today_Bento.pptx
@@ -107,7 +107,7 @@
   <p:extLst>
     <p:ext uri="{521415D9-36F7-43E2-AB2F-B90AF26B5E84}">
       <p14:sectionLst xmlns:p14="http://schemas.microsoft.com/office/powerpoint/2010/main">
-        <p14:section name="At a glance" id="{b24fe45d-1e53-887d-1e54-597b869d7cf8}">
+        <p14:section name="At a glance" id="{1c6765f4-510f-48af-e33a-72fcc59df78e}">
           <p14:sldIdLst>
             <p14:sldId id="256"/>
           </p14:sldIdLst>
@@ -964,10 +964,13 @@
               <a:buNone/>
             </a:pPr>
             <a:r>
-              <a:rPr lang="en-US" sz="2600" b="1" dirty="0">
+              <a:rPr lang="en-US" sz="2800" b="1" dirty="0">
                 <a:solidFill>
                   <a:schemeClr val="tx1"/>
                 </a:solidFill>
+                <a:latin typeface="Georgia" pitchFamily="34" charset="0"/>
+                <a:ea typeface="Georgia" pitchFamily="34" charset="-122"/>
+                <a:cs typeface="Georgia" pitchFamily="34" charset="-120"/>
               </a:rPr>
               <a:t>AI at </a:t>
             </a:r>
@@ -975,14 +978,17 @@
               <a:buNone/>
             </a:pPr>
             <a:r>
-              <a:rPr lang="en-US" sz="2600" b="1" dirty="0">
+              <a:rPr lang="en-US" sz="2800" b="1" dirty="0">
                 <a:solidFill>
                   <a:schemeClr val="accent1"/>
                 </a:solidFill>
+                <a:latin typeface="Georgia" pitchFamily="34" charset="0"/>
+                <a:ea typeface="Georgia" pitchFamily="34" charset="-122"/>
+                <a:cs typeface="Georgia" pitchFamily="34" charset="-120"/>
               </a:rPr>
               <a:t>India Today Group</a:t>
             </a:r>
-            <a:endParaRPr lang="en-US" sz="2600" dirty="0"/>
+            <a:endParaRPr lang="en-US" sz="2800" dirty="0"/>
           </a:p>
         </p:txBody>
       </p:sp>
@@ -1225,14 +1231,17 @@
               <a:buNone/>
             </a:pPr>
             <a:r>
-              <a:rPr lang="en-US" sz="1900" b="1" dirty="0">
+              <a:rPr lang="en-US" sz="1850" b="1" dirty="0">
                 <a:solidFill>
                   <a:schemeClr val="tx1"/>
                 </a:solidFill>
+                <a:latin typeface="Georgia" pitchFamily="34" charset="0"/>
+                <a:ea typeface="Georgia" pitchFamily="34" charset="-122"/>
+                <a:cs typeface="Georgia" pitchFamily="34" charset="-120"/>
               </a:rPr>
               <a:t>Real-time AI dubbing of our election coverage</a:t>
             </a:r>
-            <a:endParaRPr lang="en-US" sz="1900" dirty="0"/>
+            <a:endParaRPr lang="en-US" sz="1850" dirty="0"/>
           </a:p>
         </p:txBody>
       </p:sp>
@@ -1720,6 +1729,9 @@
                 <a:solidFill>
                   <a:schemeClr val="tx1"/>
                 </a:solidFill>
+                <a:latin typeface="Georgia" pitchFamily="34" charset="0"/>
+                <a:ea typeface="Georgia" pitchFamily="34" charset="-122"/>
+                <a:cs typeface="Georgia" pitchFamily="34" charset="-120"/>
               </a:rPr>
               <a:t>AI news anchors</a:t>
             </a:r>
@@ -1975,6 +1987,9 @@
                 <a:solidFill>
                   <a:schemeClr val="tx1"/>
                 </a:solidFill>
+                <a:latin typeface="Georgia" pitchFamily="34" charset="0"/>
+                <a:ea typeface="Georgia" pitchFamily="34" charset="-122"/>
+                <a:cs typeface="Georgia" pitchFamily="34" charset="-120"/>
               </a:rPr>
               <a:t>AI doubles of our anchors</a:t>
             </a:r>
@@ -2012,7 +2027,7 @@
                   <a:schemeClr val="tx2"/>
                 </a:solidFill>
               </a:rPr>
-              <a:t>Coverage stays live while our anchors report from the field.</a:t>
+              <a:t>Coverage stays live while anchors report from the field.</a:t>
             </a:r>
             <a:endParaRPr lang="en-US" sz="1050" dirty="0"/>
           </a:p>
@@ -2187,6 +2202,9 @@
                 <a:solidFill>
                   <a:schemeClr val="tx1"/>
                 </a:solidFill>
+                <a:latin typeface="Georgia" pitchFamily="34" charset="0"/>
+                <a:ea typeface="Georgia" pitchFamily="34" charset="-122"/>
+                <a:cs typeface="Georgia" pitchFamily="34" charset="-120"/>
               </a:rPr>
               <a:t>AI audio-visual production</a:t>
             </a:r>
@@ -2682,6 +2700,9 @@
                 <a:solidFill>
                   <a:schemeClr val="tx1"/>
                 </a:solidFill>
+                <a:latin typeface="Georgia" pitchFamily="34" charset="0"/>
+                <a:ea typeface="Georgia" pitchFamily="34" charset="-122"/>
+                <a:cs typeface="Georgia" pitchFamily="34" charset="-120"/>
               </a:rPr>
               <a:t>Operation Sindoor, fully AI-made</a:t>
             </a:r>
@@ -2719,7 +2740,21 @@
                   <a:schemeClr val="tx2"/>
                 </a:solidFill>
               </a:rPr>
-              <a:t>First in Indian news media. May 2025.</a:t>
+              <a:t>First in Indian news media,</a:t>
+            </a:r>
+            <a:endParaRPr lang="en-US" sz="900" dirty="0"/>
+          </a:p>
+          <a:p>
+            <a:pPr indent="0" marL="0">
+              <a:buNone/>
+            </a:pPr>
+            <a:r>
+              <a:rPr lang="en-US" sz="900" dirty="0">
+                <a:solidFill>
+                  <a:schemeClr val="tx2"/>
+                </a:solidFill>
+              </a:rPr>
+              <a:t>May 2025</a:t>
             </a:r>
             <a:endParaRPr lang="en-US" sz="900" dirty="0"/>
           </a:p>
@@ -2897,6 +2932,9 @@
                 <a:solidFill>
                   <a:schemeClr val="tx1"/>
                 </a:solidFill>
+                <a:latin typeface="Georgia" pitchFamily="34" charset="0"/>
+                <a:ea typeface="Georgia" pitchFamily="34" charset="-122"/>
+                <a:cs typeface="Georgia" pitchFamily="34" charset="-120"/>
               </a:rPr>
               <a:t>National anthem, recreated with AI</a:t>
             </a:r>
@@ -3071,6 +3109,9 @@
                 <a:solidFill>
                   <a:schemeClr val="tx1"/>
                 </a:solidFill>
+                <a:latin typeface="Georgia" pitchFamily="34" charset="0"/>
+                <a:ea typeface="Georgia" pitchFamily="34" charset="-122"/>
+                <a:cs typeface="Georgia" pitchFamily="34" charset="-120"/>
               </a:rPr>
               <a:t>AI-enabled CMS</a:t>
             </a:r>
@@ -3201,6 +3242,9 @@
                 <a:solidFill>
                   <a:schemeClr val="tx1"/>
                 </a:solidFill>
+                <a:latin typeface="Georgia" pitchFamily="34" charset="0"/>
+                <a:ea typeface="Georgia" pitchFamily="34" charset="-122"/>
+                <a:cs typeface="Georgia" pitchFamily="34" charset="-120"/>
               </a:rPr>
               <a:t>Routine updates, automated</a:t>
             </a:r>
@@ -3260,7 +3304,7 @@
         </p:blipFill>
         <p:spPr>
           <a:xfrm>
-            <a:off x="6330277" y="5760720"/>
+            <a:off x="6493726" y="5760720"/>
             <a:ext cx="310896" cy="310896"/>
           </a:xfrm>
           <a:prstGeom prst="rect">
@@ -3276,8 +3320,8 @@
         </p:nvSpPr>
         <p:spPr>
           <a:xfrm>
-            <a:off x="6181344" y="6126480"/>
-            <a:ext cx="608762" cy="329184"/>
+            <a:off x="6364224" y="6126480"/>
+            <a:ext cx="569900" cy="329184"/>
           </a:xfrm>
           <a:prstGeom prst="rect">
             <a:avLst/>
@@ -3320,7 +3364,7 @@
         </p:blipFill>
         <p:spPr>
           <a:xfrm>
-            <a:off x="6939039" y="5760720"/>
+            <a:off x="7063626" y="5760720"/>
             <a:ext cx="310896" cy="310896"/>
           </a:xfrm>
           <a:prstGeom prst="rect">
@@ -3336,8 +3380,8 @@
         </p:nvSpPr>
         <p:spPr>
           <a:xfrm>
-            <a:off x="6790106" y="6126480"/>
-            <a:ext cx="608762" cy="329184"/>
+            <a:off x="6934124" y="6126480"/>
+            <a:ext cx="569900" cy="329184"/>
           </a:xfrm>
           <a:prstGeom prst="rect">
             <a:avLst/>
@@ -3394,7 +3438,7 @@
         </p:blipFill>
         <p:spPr>
           <a:xfrm>
-            <a:off x="7547801" y="5760720"/>
+            <a:off x="7633526" y="5760720"/>
             <a:ext cx="310896" cy="310896"/>
           </a:xfrm>
           <a:prstGeom prst="rect">
@@ -3410,8 +3454,8 @@
         </p:nvSpPr>
         <p:spPr>
           <a:xfrm>
-            <a:off x="7398868" y="6126480"/>
-            <a:ext cx="608762" cy="329184"/>
+            <a:off x="7504024" y="6126480"/>
+            <a:ext cx="569900" cy="329184"/>
           </a:xfrm>
           <a:prstGeom prst="rect">
             <a:avLst/>
@@ -3468,7 +3512,7 @@
         </p:blipFill>
         <p:spPr>
           <a:xfrm>
-            <a:off x="8156562" y="5760720"/>
+            <a:off x="8203425" y="5760720"/>
             <a:ext cx="310896" cy="310896"/>
           </a:xfrm>
           <a:prstGeom prst="rect">
@@ -3484,8 +3528,8 @@
         </p:nvSpPr>
         <p:spPr>
           <a:xfrm>
-            <a:off x="8007629" y="6126480"/>
-            <a:ext cx="608762" cy="329184"/>
+            <a:off x="8073923" y="6126480"/>
+            <a:ext cx="569900" cy="329184"/>
           </a:xfrm>
           <a:prstGeom prst="rect">
             <a:avLst/>
@@ -3577,6 +3621,9 @@
                 <a:solidFill>
                   <a:schemeClr val="bg1"/>
                 </a:solidFill>
+                <a:latin typeface="Georgia" pitchFamily="34" charset="0"/>
+                <a:ea typeface="Georgia" pitchFamily="34" charset="-122"/>
+                <a:cs typeface="Georgia" pitchFamily="34" charset="-120"/>
               </a:rPr>
               <a:t>Truth and credibility at the heart of it.</a:t>
             </a:r>
@@ -3682,7 +3729,7 @@
     </a:clrScheme>
     <a:fontScheme name="India Today AI Bento">
       <a:majorFont>
-        <a:latin typeface="Inter"/>
+        <a:latin typeface="Georgia"/>
         <a:ea typeface=""/>
         <a:cs typeface=""/>
         <a:font script="Jpan" typeface="游ゴシック Light"/>
@@ -3734,7 +3781,7 @@
         <a:font script="Tfng" typeface="Ebrima"/>
       </a:majorFont>
       <a:minorFont>
-        <a:latin typeface="Inter"/>
+        <a:latin typeface="Arial"/>
         <a:ea typeface=""/>
         <a:cs typeface=""/>
         <a:font script="Jpan" typeface="游ゴシック"/>

</xml_diff>

<commit_message>
Rebuild bento slide around supplied images with rewritten copy
Drops the category tags, merges AI anchors with AI doubles and
Operation Sindoor with the national anthem, and places the supplied
images (dubbing graphic, anchor, AI double, Sindoor, anthem).

Co-Authored-By: Claude Opus 5.5 <noreply@anthropic.com>
Claude-Session: https://claude.ai/code/session_01XfzJZGxwThMkoxLN562VyL
</commit_message>
<xml_diff>
--- a/india-today-ai-slides/Option_C_AI_at_India_Today_Bento.pptx
+++ b/india-today-ai-slides/Option_C_AI_at_India_Today_Bento.pptx
@@ -107,7 +107,7 @@
   <p:extLst>
     <p:ext uri="{521415D9-36F7-43E2-AB2F-B90AF26B5E84}">
       <p14:sectionLst xmlns:p14="http://schemas.microsoft.com/office/powerpoint/2010/main">
-        <p14:section name="At a glance" id="{1c6765f4-510f-48af-e33a-72fcc59df78e}">
+        <p14:section name="At a glance" id="{23f955df-89fb-a148-bafe-7ea04601e76e}">
           <p14:sldIdLst>
             <p14:sldId id="256"/>
           </p14:sldIdLst>
@@ -516,7 +516,7 @@
           <a:p>
             <a:r>
               <a:rPr lang="en-US" dirty="0"/>
-              <a:t>AI at India Today Group, at a glance. On air: a first in India, real-time AI dubbing of our TV election programming into Indian regional languages; India's first AI news anchor; and AI doubles of our anchors that keep coverage live while they report from the field. Create: in-house AI voiceovers, images, video, infographics, magazine covers, illustrations and AI fashion shows, including India Today covers since 1975 brought back to life. Landmark stories: the first fully AI-made film broadcast by Indian news media, on Operation Sindoor (May 2025), and India's national anthem recreated with our freedom fighters. Newsroom ops: an AI-enabled CMS and automated weather, air quality, fuel and commodity updates. Truth and credibility stay at the heart: a 50-year legacy gearing for the next 50.</a:t>
+              <a:t>AI at India Today Group, at a glance. A first in India: our TV election programming is dubbed by AI in real time into multiple Indian languages. India's first AI news anchor is now joined by AI doubles of our own anchors, keeping bulletins on air even when the anchors are out in the field. An in-house AI studio produces voiceovers, video, graphics, infographics, magazine covers, illustrations and AI fashion shows, and has brought iconic India Today covers since 1975 back to life. Landmark stories: the first fully AI-made film from Indian news media, on Operation Sindoor (May 2025), and the national anthem voiced by India's freedom fighters, recreated in face and voice. Behind the scenes: an AI-enabled CMS, and automated weather, air quality, fuel and commodity updates. Truth and credibility stay at the heart of it: a 50-year legacy, gearing up for the next 50.</a:t>
             </a:r>
             <a:endParaRPr lang="en-US" dirty="0"/>
           </a:p>
@@ -947,8 +947,8 @@
         </p:nvSpPr>
         <p:spPr>
           <a:xfrm>
-            <a:off x="365760" y="292608"/>
-            <a:ext cx="8229600" cy="457200"/>
+            <a:off x="365760" y="274320"/>
+            <a:ext cx="8229600" cy="475488"/>
           </a:xfrm>
           <a:prstGeom prst="rect">
             <a:avLst/>
@@ -961,6 +961,9 @@
           <a:lstStyle/>
           <a:p>
             <a:pPr indent="0" marL="0">
+              <a:lnSpc>
+                <a:spcPct val="95000"/>
+              </a:lnSpc>
               <a:buNone/>
             </a:pPr>
             <a:r>
@@ -975,6 +978,9 @@
               <a:t>AI at </a:t>
             </a:r>
             <a:pPr indent="0" marL="0">
+              <a:lnSpc>
+                <a:spcPct val="95000"/>
+              </a:lnSpc>
               <a:buNone/>
             </a:pPr>
             <a:r>
@@ -1000,7 +1006,7 @@
         </p:nvSpPr>
         <p:spPr>
           <a:xfrm>
-            <a:off x="365760" y="768096"/>
+            <a:off x="365760" y="786384"/>
             <a:ext cx="10058400" cy="274320"/>
           </a:xfrm>
           <a:prstGeom prst="rect">
@@ -1017,91 +1023,14 @@
               <a:buNone/>
             </a:pPr>
             <a:r>
-              <a:rPr lang="en-US" sz="1250" dirty="0">
+              <a:rPr lang="en-US" sz="1300" dirty="0">
                 <a:solidFill>
                   <a:schemeClr val="tx2"/>
                 </a:solidFill>
               </a:rPr>
-              <a:t>One newsroom, four ways AI works for it:  </a:t>
-            </a:r>
-            <a:pPr indent="0" marL="0">
-              <a:buNone/>
-            </a:pPr>
-            <a:r>
-              <a:rPr lang="en-US" sz="1250" b="1" dirty="0">
-                <a:solidFill>
-                  <a:schemeClr val="accent1"/>
-                </a:solidFill>
-              </a:rPr>
-              <a:t>On air</a:t>
-            </a:r>
-            <a:pPr indent="0" marL="0">
-              <a:buNone/>
-            </a:pPr>
-            <a:r>
-              <a:rPr lang="en-US" sz="1250" dirty="0">
-                <a:solidFill>
-                  <a:schemeClr val="tx2"/>
-                </a:solidFill>
-              </a:rPr>
-              <a:t>  ·  </a:t>
-            </a:r>
-            <a:pPr indent="0" marL="0">
-              <a:buNone/>
-            </a:pPr>
-            <a:r>
-              <a:rPr lang="en-US" sz="1250" b="1" dirty="0">
-                <a:solidFill>
-                  <a:schemeClr val="accent2"/>
-                </a:solidFill>
-              </a:rPr>
-              <a:t>Create</a:t>
-            </a:r>
-            <a:pPr indent="0" marL="0">
-              <a:buNone/>
-            </a:pPr>
-            <a:r>
-              <a:rPr lang="en-US" sz="1250" dirty="0">
-                <a:solidFill>
-                  <a:schemeClr val="tx2"/>
-                </a:solidFill>
-              </a:rPr>
-              <a:t>  ·  </a:t>
-            </a:r>
-            <a:pPr indent="0" marL="0">
-              <a:buNone/>
-            </a:pPr>
-            <a:r>
-              <a:rPr lang="en-US" sz="1250" b="1" dirty="0">
-                <a:solidFill>
-                  <a:schemeClr val="accent3"/>
-                </a:solidFill>
-              </a:rPr>
-              <a:t>Landmark stories</a:t>
-            </a:r>
-            <a:pPr indent="0" marL="0">
-              <a:buNone/>
-            </a:pPr>
-            <a:r>
-              <a:rPr lang="en-US" sz="1250" dirty="0">
-                <a:solidFill>
-                  <a:schemeClr val="tx2"/>
-                </a:solidFill>
-              </a:rPr>
-              <a:t>  ·  </a:t>
-            </a:r>
-            <a:pPr indent="0" marL="0">
-              <a:buNone/>
-            </a:pPr>
-            <a:r>
-              <a:rPr lang="en-US" sz="1250" b="1" dirty="0">
-                <a:solidFill>
-                  <a:schemeClr val="accent4"/>
-                </a:solidFill>
-              </a:rPr>
-              <a:t>Newsroom ops</a:t>
-            </a:r>
-            <a:endParaRPr lang="en-US" sz="1250" dirty="0"/>
+              <a:t>Built into the newsroom, not bolted on: AI now shapes how we report, produce and deliver the news.</a:t>
+            </a:r>
+            <a:endParaRPr lang="en-US" sz="1300" dirty="0"/>
           </a:p>
         </p:txBody>
       </p:sp>
@@ -1122,56 +1051,20 @@
             </a:avLst>
           </a:prstGeom>
           <a:solidFill>
-            <a:srgbClr val="FFF3F3"/>
-          </a:solidFill>
-          <a:ln/>
-        </p:spPr>
-      </p:sp>
-      <p:sp>
-        <p:nvSpPr>
-          <p:cNvPr id="5" name="Text 3"/>
-          <p:cNvSpPr txBox="1"/>
-          <p:nvPr/>
-        </p:nvSpPr>
-        <p:spPr>
-          <a:xfrm>
-            <a:off x="621792" y="1536192"/>
-            <a:ext cx="2194560" cy="182880"/>
-          </a:xfrm>
-          <a:prstGeom prst="rect">
-            <a:avLst/>
-          </a:prstGeom>
-          <a:noFill/>
-          <a:ln/>
-        </p:spPr>
-        <p:txBody>
-          <a:bodyPr wrap="square" lIns="0" tIns="0" rIns="0" bIns="0" rtlCol="0" anchor="t"/>
-          <a:lstStyle/>
-          <a:p>
-            <a:pPr indent="0" marL="0">
-              <a:buNone/>
-            </a:pPr>
-            <a:r>
-              <a:rPr lang="en-US" sz="900" b="1" spc="120" kern="0" dirty="0">
-                <a:solidFill>
-                  <a:schemeClr val="accent1"/>
-                </a:solidFill>
-              </a:rPr>
-              <a:t>ON AIR</a:t>
-            </a:r>
-            <a:endParaRPr lang="en-US" sz="900" dirty="0"/>
-          </a:p>
-        </p:txBody>
-      </p:sp>
-      <p:sp>
-        <p:nvSpPr>
-          <p:cNvPr id="6" name="Badge FIRST IN INDIA"/>
-          <p:cNvSpPr txBox="1"/>
-          <p:nvPr/>
-        </p:nvSpPr>
-        <p:spPr>
-          <a:xfrm>
-            <a:off x="2926080" y="1499616"/>
+            <a:srgbClr val="FFFFFF"/>
+          </a:solidFill>
+          <a:ln/>
+        </p:spPr>
+      </p:sp>
+      <p:sp>
+        <p:nvSpPr>
+          <p:cNvPr id="5" name="Badge"/>
+          <p:cNvSpPr txBox="1"/>
+          <p:nvPr/>
+        </p:nvSpPr>
+        <p:spPr>
+          <a:xfrm>
+            <a:off x="621792" y="1517904"/>
             <a:ext cx="1024128" cy="219456"/>
           </a:xfrm>
           <a:prstGeom prst="roundRect">
@@ -1205,13 +1098,13 @@
       </p:sp>
       <p:sp>
         <p:nvSpPr>
-          <p:cNvPr id="7" name="Text 5"/>
-          <p:cNvSpPr txBox="1"/>
-          <p:nvPr/>
-        </p:nvSpPr>
-        <p:spPr>
-          <a:xfrm>
-            <a:off x="621792" y="1828800"/>
+          <p:cNvPr id="6" name="Text 4"/>
+          <p:cNvSpPr txBox="1"/>
+          <p:nvPr/>
+        </p:nvSpPr>
+        <p:spPr>
+          <a:xfrm>
+            <a:off x="621792" y="1847088"/>
             <a:ext cx="3328416" cy="658368"/>
           </a:xfrm>
           <a:prstGeom prst="rect">
@@ -1231,7 +1124,7 @@
               <a:buNone/>
             </a:pPr>
             <a:r>
-              <a:rPr lang="en-US" sz="1850" b="1" dirty="0">
+              <a:rPr lang="en-US" sz="1900" b="1" dirty="0">
                 <a:solidFill>
                   <a:schemeClr val="tx1"/>
                 </a:solidFill>
@@ -1239,22 +1132,22 @@
                 <a:ea typeface="Georgia" pitchFamily="34" charset="-122"/>
                 <a:cs typeface="Georgia" pitchFamily="34" charset="-120"/>
               </a:rPr>
-              <a:t>Real-time AI dubbing of our election coverage</a:t>
-            </a:r>
-            <a:endParaRPr lang="en-US" sz="1850" dirty="0"/>
-          </a:p>
-        </p:txBody>
-      </p:sp>
-      <p:sp>
-        <p:nvSpPr>
-          <p:cNvPr id="8" name="Text 6"/>
-          <p:cNvSpPr txBox="1"/>
-          <p:nvPr/>
-        </p:nvSpPr>
-        <p:spPr>
-          <a:xfrm>
-            <a:off x="621792" y="2542032"/>
-            <a:ext cx="3328416" cy="658368"/>
+              <a:t>Election coverage, live in every language</a:t>
+            </a:r>
+            <a:endParaRPr lang="en-US" sz="1900" dirty="0"/>
+          </a:p>
+        </p:txBody>
+      </p:sp>
+      <p:sp>
+        <p:nvSpPr>
+          <p:cNvPr id="7" name="Text 5"/>
+          <p:cNvSpPr txBox="1"/>
+          <p:nvPr/>
+        </p:nvSpPr>
+        <p:spPr>
+          <a:xfrm>
+            <a:off x="621792" y="2578608"/>
+            <a:ext cx="3328416" cy="749808"/>
           </a:xfrm>
           <a:prstGeom prst="rect">
             <a:avLst/>
@@ -1275,37 +1168,15 @@
                   <a:schemeClr val="tx2"/>
                 </a:solidFill>
               </a:rPr>
-              <a:t>Live TV election programming, dubbed by AI into Indian regional languages as it airs, so every viewer follows the count in their own language.</a:t>
+              <a:t>Our TV election programming is dubbed by AI in real time into multiple Indian languages, so viewers across the country follow the results as they unfold, in the language they think in.</a:t>
             </a:r>
             <a:endParaRPr lang="en-US" sz="1050" dirty="0"/>
           </a:p>
         </p:txBody>
-      </p:sp>
-      <p:sp>
-        <p:nvSpPr>
-          <p:cNvPr id="9" name="IMAGE SLOT - Election studio / dubbed broadcast"/>
-          <p:cNvSpPr/>
-          <p:nvPr/>
-        </p:nvSpPr>
-        <p:spPr>
-          <a:xfrm>
-            <a:off x="621792" y="3273552"/>
-            <a:ext cx="3328416" cy="1508760"/>
-          </a:xfrm>
-          <a:prstGeom prst="roundRect">
-            <a:avLst>
-              <a:gd name="adj" fmla="val 7273"/>
-            </a:avLst>
-          </a:prstGeom>
-          <a:solidFill>
-            <a:srgbClr val="E6E6EB"/>
-          </a:solidFill>
-          <a:ln/>
-        </p:spPr>
       </p:sp>
       <p:pic>
         <p:nvPicPr>
-          <p:cNvPr id="10" name="slot icon - Election studio / dubbed broadcast" descr="preencoded.png">    </p:cNvPr>
+          <p:cNvPr id="8" name="Dubbing visual" descr="/tmp/claude-0/-home-user-nayak/e234e072-51fc-5a89-bcc1-7181d2d8a173/scratchpad/build/assets/u_dubbing.png">    </p:cNvPr>
           <p:cNvPicPr>
             <a:picLocks noChangeAspect="1"/>
           </p:cNvPicPr>
@@ -1319,8 +1190,8 @@
         </p:blipFill>
         <p:spPr>
           <a:xfrm>
-            <a:off x="2139696" y="3771900"/>
-            <a:ext cx="292608" cy="292608"/>
+            <a:off x="621792" y="3392424"/>
+            <a:ext cx="3328416" cy="1874520"/>
           </a:xfrm>
           <a:prstGeom prst="rect">
             <a:avLst/>
@@ -1329,50 +1200,36 @@
       </p:pic>
       <p:sp>
         <p:nvSpPr>
-          <p:cNvPr id="11" name="Text 8"/>
-          <p:cNvSpPr txBox="1"/>
-          <p:nvPr/>
-        </p:nvSpPr>
-        <p:spPr>
-          <a:xfrm>
-            <a:off x="713232" y="4119372"/>
-            <a:ext cx="3145536" cy="201168"/>
-          </a:xfrm>
-          <a:prstGeom prst="rect">
-            <a:avLst/>
-          </a:prstGeom>
-          <a:noFill/>
-          <a:ln/>
-        </p:spPr>
-        <p:txBody>
-          <a:bodyPr wrap="square" lIns="0" tIns="0" rIns="0" bIns="0" rtlCol="0" anchor="t"/>
-          <a:lstStyle/>
-          <a:p>
-            <a:pPr algn="ctr" indent="0" marL="0">
-              <a:buNone/>
-            </a:pPr>
-            <a:r>
-              <a:rPr lang="en-US" sz="850" dirty="0">
-                <a:solidFill>
-                  <a:schemeClr val="tx2"/>
-                </a:solidFill>
-              </a:rPr>
-              <a:t>Election studio / dubbed broadcast</a:t>
-            </a:r>
-            <a:endParaRPr lang="en-US" sz="850" dirty="0"/>
-          </a:p>
-        </p:txBody>
-      </p:sp>
-      <p:sp>
-        <p:nvSpPr>
-          <p:cNvPr id="12" name="Chip ● LIVE"/>
-          <p:cNvSpPr txBox="1"/>
-          <p:nvPr/>
-        </p:nvSpPr>
-        <p:spPr>
-          <a:xfrm>
-            <a:off x="621792" y="4992624"/>
-            <a:ext cx="566928" cy="256032"/>
+          <p:cNvPr id="9" name="Tile - AI anchors and doubles"/>
+          <p:cNvSpPr/>
+          <p:nvPr/>
+        </p:nvSpPr>
+        <p:spPr>
+          <a:xfrm>
+            <a:off x="4352544" y="1261872"/>
+            <a:ext cx="7473391" cy="2011680"/>
+          </a:xfrm>
+          <a:prstGeom prst="roundRect">
+            <a:avLst>
+              <a:gd name="adj" fmla="val 9091"/>
+            </a:avLst>
+          </a:prstGeom>
+          <a:solidFill>
+            <a:srgbClr val="FFFFFF"/>
+          </a:solidFill>
+          <a:ln/>
+        </p:spPr>
+      </p:sp>
+      <p:sp>
+        <p:nvSpPr>
+          <p:cNvPr id="10" name="Badge"/>
+          <p:cNvSpPr txBox="1"/>
+          <p:nvPr/>
+        </p:nvSpPr>
+        <p:spPr>
+          <a:xfrm>
+            <a:off x="4608576" y="1517904"/>
+            <a:ext cx="1024128" cy="219456"/>
           </a:xfrm>
           <a:prstGeom prst="roundRect">
             <a:avLst>
@@ -1392,300 +1249,6 @@
               <a:buNone/>
             </a:pPr>
             <a:r>
-              <a:rPr lang="en-US" sz="850" dirty="0">
-                <a:solidFill>
-                  <a:srgbClr val="FFFFFF"/>
-                </a:solidFill>
-              </a:rPr>
-              <a:t>● LIVE</a:t>
-            </a:r>
-            <a:endParaRPr lang="en-US" sz="850" dirty="0"/>
-          </a:p>
-        </p:txBody>
-      </p:sp>
-      <p:sp>
-        <p:nvSpPr>
-          <p:cNvPr id="13" name="Text 10"/>
-          <p:cNvSpPr txBox="1"/>
-          <p:nvPr/>
-        </p:nvSpPr>
-        <p:spPr>
-          <a:xfrm>
-            <a:off x="1225296" y="4992624"/>
-            <a:ext cx="182880" cy="256032"/>
-          </a:xfrm>
-          <a:prstGeom prst="rect">
-            <a:avLst/>
-          </a:prstGeom>
-          <a:noFill/>
-          <a:ln/>
-        </p:spPr>
-        <p:txBody>
-          <a:bodyPr wrap="square" lIns="0" tIns="0" rIns="0" bIns="0" rtlCol="0" anchor="ctr"/>
-          <a:lstStyle/>
-          <a:p>
-            <a:pPr algn="ctr" indent="0" marL="0">
-              <a:buNone/>
-            </a:pPr>
-            <a:r>
-              <a:rPr lang="en-US" sz="1100" dirty="0">
-                <a:solidFill>
-                  <a:schemeClr val="tx2"/>
-                </a:solidFill>
-              </a:rPr>
-              <a:t>→</a:t>
-            </a:r>
-            <a:endParaRPr lang="en-US" sz="1100" dirty="0"/>
-          </a:p>
-        </p:txBody>
-      </p:sp>
-      <p:sp>
-        <p:nvSpPr>
-          <p:cNvPr id="14" name="Chip Bengali"/>
-          <p:cNvSpPr txBox="1"/>
-          <p:nvPr/>
-        </p:nvSpPr>
-        <p:spPr>
-          <a:xfrm>
-            <a:off x="1444752" y="4992624"/>
-            <a:ext cx="585216" cy="256032"/>
-          </a:xfrm>
-          <a:prstGeom prst="roundRect">
-            <a:avLst>
-              <a:gd name="adj" fmla="val 50000"/>
-            </a:avLst>
-          </a:prstGeom>
-          <a:solidFill>
-            <a:srgbClr val="FFFFFF"/>
-          </a:solidFill>
-          <a:ln/>
-        </p:spPr>
-        <p:txBody>
-          <a:bodyPr wrap="square" lIns="0" tIns="0" rIns="0" bIns="0" rtlCol="0" anchor="ctr"/>
-          <a:lstStyle/>
-          <a:p>
-            <a:pPr algn="ctr" indent="0" marL="0">
-              <a:buNone/>
-            </a:pPr>
-            <a:r>
-              <a:rPr lang="en-US" sz="850" dirty="0">
-                <a:solidFill>
-                  <a:srgbClr val="1D1D1F"/>
-                </a:solidFill>
-              </a:rPr>
-              <a:t>Bengali</a:t>
-            </a:r>
-            <a:endParaRPr lang="en-US" sz="850" dirty="0"/>
-          </a:p>
-        </p:txBody>
-      </p:sp>
-      <p:sp>
-        <p:nvSpPr>
-          <p:cNvPr id="15" name="Chip Tamil"/>
-          <p:cNvSpPr txBox="1"/>
-          <p:nvPr/>
-        </p:nvSpPr>
-        <p:spPr>
-          <a:xfrm>
-            <a:off x="2075688" y="4992624"/>
-            <a:ext cx="475488" cy="256032"/>
-          </a:xfrm>
-          <a:prstGeom prst="roundRect">
-            <a:avLst>
-              <a:gd name="adj" fmla="val 50000"/>
-            </a:avLst>
-          </a:prstGeom>
-          <a:solidFill>
-            <a:srgbClr val="FFFFFF"/>
-          </a:solidFill>
-          <a:ln/>
-        </p:spPr>
-        <p:txBody>
-          <a:bodyPr wrap="square" lIns="0" tIns="0" rIns="0" bIns="0" rtlCol="0" anchor="ctr"/>
-          <a:lstStyle/>
-          <a:p>
-            <a:pPr algn="ctr" indent="0" marL="0">
-              <a:buNone/>
-            </a:pPr>
-            <a:r>
-              <a:rPr lang="en-US" sz="850" dirty="0">
-                <a:solidFill>
-                  <a:srgbClr val="1D1D1F"/>
-                </a:solidFill>
-              </a:rPr>
-              <a:t>Tamil</a:t>
-            </a:r>
-            <a:endParaRPr lang="en-US" sz="850" dirty="0"/>
-          </a:p>
-        </p:txBody>
-      </p:sp>
-      <p:sp>
-        <p:nvSpPr>
-          <p:cNvPr id="16" name="Chip Telugu"/>
-          <p:cNvSpPr txBox="1"/>
-          <p:nvPr/>
-        </p:nvSpPr>
-        <p:spPr>
-          <a:xfrm>
-            <a:off x="2596896" y="4992624"/>
-            <a:ext cx="548640" cy="256032"/>
-          </a:xfrm>
-          <a:prstGeom prst="roundRect">
-            <a:avLst>
-              <a:gd name="adj" fmla="val 50000"/>
-            </a:avLst>
-          </a:prstGeom>
-          <a:solidFill>
-            <a:srgbClr val="FFFFFF"/>
-          </a:solidFill>
-          <a:ln/>
-        </p:spPr>
-        <p:txBody>
-          <a:bodyPr wrap="square" lIns="0" tIns="0" rIns="0" bIns="0" rtlCol="0" anchor="ctr"/>
-          <a:lstStyle/>
-          <a:p>
-            <a:pPr algn="ctr" indent="0" marL="0">
-              <a:buNone/>
-            </a:pPr>
-            <a:r>
-              <a:rPr lang="en-US" sz="850" dirty="0">
-                <a:solidFill>
-                  <a:srgbClr val="1D1D1F"/>
-                </a:solidFill>
-              </a:rPr>
-              <a:t>Telugu</a:t>
-            </a:r>
-            <a:endParaRPr lang="en-US" sz="850" dirty="0"/>
-          </a:p>
-        </p:txBody>
-      </p:sp>
-      <p:sp>
-        <p:nvSpPr>
-          <p:cNvPr id="17" name="Chip Marathi"/>
-          <p:cNvSpPr txBox="1"/>
-          <p:nvPr/>
-        </p:nvSpPr>
-        <p:spPr>
-          <a:xfrm>
-            <a:off x="3191256" y="4992624"/>
-            <a:ext cx="603504" cy="256032"/>
-          </a:xfrm>
-          <a:prstGeom prst="roundRect">
-            <a:avLst>
-              <a:gd name="adj" fmla="val 50000"/>
-            </a:avLst>
-          </a:prstGeom>
-          <a:solidFill>
-            <a:srgbClr val="FFFFFF"/>
-          </a:solidFill>
-          <a:ln/>
-        </p:spPr>
-        <p:txBody>
-          <a:bodyPr wrap="square" lIns="0" tIns="0" rIns="0" bIns="0" rtlCol="0" anchor="ctr"/>
-          <a:lstStyle/>
-          <a:p>
-            <a:pPr algn="ctr" indent="0" marL="0">
-              <a:buNone/>
-            </a:pPr>
-            <a:r>
-              <a:rPr lang="en-US" sz="850" dirty="0">
-                <a:solidFill>
-                  <a:srgbClr val="1D1D1F"/>
-                </a:solidFill>
-              </a:rPr>
-              <a:t>Marathi</a:t>
-            </a:r>
-            <a:endParaRPr lang="en-US" sz="850" dirty="0"/>
-          </a:p>
-        </p:txBody>
-      </p:sp>
-      <p:sp>
-        <p:nvSpPr>
-          <p:cNvPr id="18" name="Tile - AI anchors"/>
-          <p:cNvSpPr/>
-          <p:nvPr/>
-        </p:nvSpPr>
-        <p:spPr>
-          <a:xfrm>
-            <a:off x="4352544" y="1261872"/>
-            <a:ext cx="3663544" cy="2011680"/>
-          </a:xfrm>
-          <a:prstGeom prst="roundRect">
-            <a:avLst>
-              <a:gd name="adj" fmla="val 9091"/>
-            </a:avLst>
-          </a:prstGeom>
-          <a:solidFill>
-            <a:srgbClr val="FFFFFF"/>
-          </a:solidFill>
-          <a:ln/>
-        </p:spPr>
-      </p:sp>
-      <p:sp>
-        <p:nvSpPr>
-          <p:cNvPr id="19" name="Text 16"/>
-          <p:cNvSpPr txBox="1"/>
-          <p:nvPr/>
-        </p:nvSpPr>
-        <p:spPr>
-          <a:xfrm>
-            <a:off x="4608576" y="1536192"/>
-            <a:ext cx="1606144" cy="182880"/>
-          </a:xfrm>
-          <a:prstGeom prst="rect">
-            <a:avLst/>
-          </a:prstGeom>
-          <a:noFill/>
-          <a:ln/>
-        </p:spPr>
-        <p:txBody>
-          <a:bodyPr wrap="square" lIns="0" tIns="0" rIns="0" bIns="0" rtlCol="0" anchor="t"/>
-          <a:lstStyle/>
-          <a:p>
-            <a:pPr indent="0" marL="0">
-              <a:buNone/>
-            </a:pPr>
-            <a:r>
-              <a:rPr lang="en-US" sz="900" b="1" spc="120" kern="0" dirty="0">
-                <a:solidFill>
-                  <a:schemeClr val="accent1"/>
-                </a:solidFill>
-              </a:rPr>
-              <a:t>ON AIR</a:t>
-            </a:r>
-            <a:endParaRPr lang="en-US" sz="900" dirty="0"/>
-          </a:p>
-        </p:txBody>
-      </p:sp>
-      <p:sp>
-        <p:nvSpPr>
-          <p:cNvPr id="20" name="Badge FIRST IN INDIA"/>
-          <p:cNvSpPr txBox="1"/>
-          <p:nvPr/>
-        </p:nvSpPr>
-        <p:spPr>
-          <a:xfrm>
-            <a:off x="4608576" y="2962656"/>
-            <a:ext cx="1024128" cy="219456"/>
-          </a:xfrm>
-          <a:prstGeom prst="roundRect">
-            <a:avLst>
-              <a:gd name="adj" fmla="val 50000"/>
-            </a:avLst>
-          </a:prstGeom>
-          <a:solidFill>
-            <a:srgbClr val="E31E24"/>
-          </a:solidFill>
-          <a:ln/>
-        </p:spPr>
-        <p:txBody>
-          <a:bodyPr wrap="square" lIns="0" tIns="0" rIns="0" bIns="0" rtlCol="0" anchor="ctr"/>
-          <a:lstStyle/>
-          <a:p>
-            <a:pPr algn="ctr" indent="0" marL="0">
-              <a:buNone/>
-            </a:pPr>
-            <a:r>
               <a:rPr lang="en-US" sz="750" b="1" spc="80" kern="0" dirty="0">
                 <a:solidFill>
                   <a:schemeClr val="bg1"/>
@@ -1699,14 +1262,14 @@
       </p:sp>
       <p:sp>
         <p:nvSpPr>
-          <p:cNvPr id="21" name="Text 18"/>
-          <p:cNvSpPr txBox="1"/>
-          <p:nvPr/>
-        </p:nvSpPr>
-        <p:spPr>
-          <a:xfrm>
-            <a:off x="4608576" y="1792224"/>
-            <a:ext cx="1606144" cy="548640"/>
+          <p:cNvPr id="11" name="Text 8"/>
+          <p:cNvSpPr txBox="1"/>
+          <p:nvPr/>
+        </p:nvSpPr>
+        <p:spPr>
+          <a:xfrm>
+            <a:off x="4608576" y="1847088"/>
+            <a:ext cx="3108960" cy="329184"/>
           </a:xfrm>
           <a:prstGeom prst="rect">
             <a:avLst/>
@@ -1725,7 +1288,7 @@
               <a:buNone/>
             </a:pPr>
             <a:r>
-              <a:rPr lang="en-US" sz="1500" b="1" dirty="0">
+              <a:rPr lang="en-US" sz="1600" b="1" dirty="0">
                 <a:solidFill>
                   <a:schemeClr val="tx1"/>
                 </a:solidFill>
@@ -1733,22 +1296,22 @@
                 <a:ea typeface="Georgia" pitchFamily="34" charset="-122"/>
                 <a:cs typeface="Georgia" pitchFamily="34" charset="-120"/>
               </a:rPr>
-              <a:t>AI news anchors</a:t>
-            </a:r>
-            <a:endParaRPr lang="en-US" sz="1500" dirty="0"/>
-          </a:p>
-        </p:txBody>
-      </p:sp>
-      <p:sp>
-        <p:nvSpPr>
-          <p:cNvPr id="22" name="Text 19"/>
-          <p:cNvSpPr txBox="1"/>
-          <p:nvPr/>
-        </p:nvSpPr>
-        <p:spPr>
-          <a:xfrm>
-            <a:off x="4608576" y="2359152"/>
-            <a:ext cx="1606144" cy="566928"/>
+              <a:t>AI anchors and AI doubles</a:t>
+            </a:r>
+            <a:endParaRPr lang="en-US" sz="1600" dirty="0"/>
+          </a:p>
+        </p:txBody>
+      </p:sp>
+      <p:sp>
+        <p:nvSpPr>
+          <p:cNvPr id="12" name="Text 9"/>
+          <p:cNvSpPr txBox="1"/>
+          <p:nvPr/>
+        </p:nvSpPr>
+        <p:spPr>
+          <a:xfrm>
+            <a:off x="4608576" y="2249424"/>
+            <a:ext cx="3108960" cy="777240"/>
           </a:xfrm>
           <a:prstGeom prst="rect">
             <a:avLst/>
@@ -1769,37 +1332,15 @@
                   <a:schemeClr val="tx2"/>
                 </a:solidFill>
               </a:rPr>
-              <a:t>India's first AI news anchor, presenting bulletins on air.</a:t>
+              <a:t>India's first AI news anchor, now joined by AI doubles of our own anchors. Bulletins stay on air around the clock, even when the anchors are out in the field.</a:t>
             </a:r>
             <a:endParaRPr lang="en-US" sz="1050" dirty="0"/>
           </a:p>
         </p:txBody>
-      </p:sp>
-      <p:sp>
-        <p:nvSpPr>
-          <p:cNvPr id="23" name="IMAGE SLOT - AI anchor"/>
-          <p:cNvSpPr/>
-          <p:nvPr/>
-        </p:nvSpPr>
-        <p:spPr>
-          <a:xfrm>
-            <a:off x="6233008" y="1444752"/>
-            <a:ext cx="1600200" cy="1645920"/>
-          </a:xfrm>
-          <a:prstGeom prst="roundRect">
-            <a:avLst>
-              <a:gd name="adj" fmla="val 6857"/>
-            </a:avLst>
-          </a:prstGeom>
-          <a:solidFill>
-            <a:srgbClr val="E6E6EB"/>
-          </a:solidFill>
-          <a:ln/>
-        </p:spPr>
       </p:sp>
       <p:pic>
         <p:nvPicPr>
-          <p:cNvPr id="24" name="slot icon - AI anchor" descr="preencoded.png">    </p:cNvPr>
+          <p:cNvPr id="13" name="AI anchor image" descr="/tmp/claude-0/-home-user-nayak/e234e072-51fc-5a89-bcc1-7181d2d8a173/scratchpad/build/assets/u_anchor.png">    </p:cNvPr>
           <p:cNvPicPr>
             <a:picLocks noChangeAspect="1"/>
           </p:cNvPicPr>
@@ -1813,251 +1354,17 @@
         </p:blipFill>
         <p:spPr>
           <a:xfrm>
-            <a:off x="6886804" y="2011680"/>
-            <a:ext cx="292608" cy="292608"/>
+            <a:off x="7875727" y="1444752"/>
+            <a:ext cx="1819656" cy="1645920"/>
           </a:xfrm>
           <a:prstGeom prst="rect">
             <a:avLst/>
           </a:prstGeom>
         </p:spPr>
       </p:pic>
-      <p:sp>
-        <p:nvSpPr>
-          <p:cNvPr id="25" name="Text 21"/>
-          <p:cNvSpPr txBox="1"/>
-          <p:nvPr/>
-        </p:nvSpPr>
-        <p:spPr>
-          <a:xfrm>
-            <a:off x="6324448" y="2359152"/>
-            <a:ext cx="1417320" cy="201168"/>
-          </a:xfrm>
-          <a:prstGeom prst="rect">
-            <a:avLst/>
-          </a:prstGeom>
-          <a:noFill/>
-          <a:ln/>
-        </p:spPr>
-        <p:txBody>
-          <a:bodyPr wrap="square" lIns="0" tIns="0" rIns="0" bIns="0" rtlCol="0" anchor="t"/>
-          <a:lstStyle/>
-          <a:p>
-            <a:pPr algn="ctr" indent="0" marL="0">
-              <a:buNone/>
-            </a:pPr>
-            <a:r>
-              <a:rPr lang="en-US" sz="850" dirty="0">
-                <a:solidFill>
-                  <a:schemeClr val="tx2"/>
-                </a:solidFill>
-              </a:rPr>
-              <a:t>AI anchor</a:t>
-            </a:r>
-            <a:endParaRPr lang="en-US" sz="850" dirty="0"/>
-          </a:p>
-        </p:txBody>
-      </p:sp>
-      <p:sp>
-        <p:nvSpPr>
-          <p:cNvPr id="26" name="Tile - AI doubles"/>
-          <p:cNvSpPr/>
-          <p:nvPr/>
-        </p:nvSpPr>
-        <p:spPr>
-          <a:xfrm>
-            <a:off x="8162392" y="1261872"/>
-            <a:ext cx="3663544" cy="2011680"/>
-          </a:xfrm>
-          <a:prstGeom prst="roundRect">
-            <a:avLst>
-              <a:gd name="adj" fmla="val 9091"/>
-            </a:avLst>
-          </a:prstGeom>
-          <a:solidFill>
-            <a:srgbClr val="FFFFFF"/>
-          </a:solidFill>
-          <a:ln/>
-        </p:spPr>
-      </p:sp>
-      <p:sp>
-        <p:nvSpPr>
-          <p:cNvPr id="27" name="Text 23"/>
-          <p:cNvSpPr txBox="1"/>
-          <p:nvPr/>
-        </p:nvSpPr>
-        <p:spPr>
-          <a:xfrm>
-            <a:off x="8418424" y="1536192"/>
-            <a:ext cx="1606144" cy="182880"/>
-          </a:xfrm>
-          <a:prstGeom prst="rect">
-            <a:avLst/>
-          </a:prstGeom>
-          <a:noFill/>
-          <a:ln/>
-        </p:spPr>
-        <p:txBody>
-          <a:bodyPr wrap="square" lIns="0" tIns="0" rIns="0" bIns="0" rtlCol="0" anchor="t"/>
-          <a:lstStyle/>
-          <a:p>
-            <a:pPr indent="0" marL="0">
-              <a:buNone/>
-            </a:pPr>
-            <a:r>
-              <a:rPr lang="en-US" sz="900" b="1" spc="120" kern="0" dirty="0">
-                <a:solidFill>
-                  <a:schemeClr val="accent1"/>
-                </a:solidFill>
-              </a:rPr>
-              <a:t>ON AIR</a:t>
-            </a:r>
-            <a:endParaRPr lang="en-US" sz="900" dirty="0"/>
-          </a:p>
-        </p:txBody>
-      </p:sp>
-      <p:sp>
-        <p:nvSpPr>
-          <p:cNvPr id="28" name="Badge FIRST IN INDIA"/>
-          <p:cNvSpPr txBox="1"/>
-          <p:nvPr/>
-        </p:nvSpPr>
-        <p:spPr>
-          <a:xfrm>
-            <a:off x="8418424" y="2962656"/>
-            <a:ext cx="1024128" cy="219456"/>
-          </a:xfrm>
-          <a:prstGeom prst="roundRect">
-            <a:avLst>
-              <a:gd name="adj" fmla="val 50000"/>
-            </a:avLst>
-          </a:prstGeom>
-          <a:solidFill>
-            <a:srgbClr val="E31E24"/>
-          </a:solidFill>
-          <a:ln/>
-        </p:spPr>
-        <p:txBody>
-          <a:bodyPr wrap="square" lIns="0" tIns="0" rIns="0" bIns="0" rtlCol="0" anchor="ctr"/>
-          <a:lstStyle/>
-          <a:p>
-            <a:pPr algn="ctr" indent="0" marL="0">
-              <a:buNone/>
-            </a:pPr>
-            <a:r>
-              <a:rPr lang="en-US" sz="750" b="1" spc="80" kern="0" dirty="0">
-                <a:solidFill>
-                  <a:schemeClr val="bg1"/>
-                </a:solidFill>
-              </a:rPr>
-              <a:t>FIRST IN INDIA</a:t>
-            </a:r>
-            <a:endParaRPr lang="en-US" sz="750" dirty="0"/>
-          </a:p>
-        </p:txBody>
-      </p:sp>
-      <p:sp>
-        <p:nvSpPr>
-          <p:cNvPr id="29" name="Text 25"/>
-          <p:cNvSpPr txBox="1"/>
-          <p:nvPr/>
-        </p:nvSpPr>
-        <p:spPr>
-          <a:xfrm>
-            <a:off x="8418424" y="1792224"/>
-            <a:ext cx="1606144" cy="548640"/>
-          </a:xfrm>
-          <a:prstGeom prst="rect">
-            <a:avLst/>
-          </a:prstGeom>
-          <a:noFill/>
-          <a:ln/>
-        </p:spPr>
-        <p:txBody>
-          <a:bodyPr wrap="square" lIns="0" tIns="0" rIns="0" bIns="0" rtlCol="0" anchor="t"/>
-          <a:lstStyle/>
-          <a:p>
-            <a:pPr indent="0" marL="0">
-              <a:lnSpc>
-                <a:spcPct val="95000"/>
-              </a:lnSpc>
-              <a:buNone/>
-            </a:pPr>
-            <a:r>
-              <a:rPr lang="en-US" sz="1500" b="1" dirty="0">
-                <a:solidFill>
-                  <a:schemeClr val="tx1"/>
-                </a:solidFill>
-                <a:latin typeface="Georgia" pitchFamily="34" charset="0"/>
-                <a:ea typeface="Georgia" pitchFamily="34" charset="-122"/>
-                <a:cs typeface="Georgia" pitchFamily="34" charset="-120"/>
-              </a:rPr>
-              <a:t>AI doubles of our anchors</a:t>
-            </a:r>
-            <a:endParaRPr lang="en-US" sz="1500" dirty="0"/>
-          </a:p>
-        </p:txBody>
-      </p:sp>
-      <p:sp>
-        <p:nvSpPr>
-          <p:cNvPr id="30" name="Text 26"/>
-          <p:cNvSpPr txBox="1"/>
-          <p:nvPr/>
-        </p:nvSpPr>
-        <p:spPr>
-          <a:xfrm>
-            <a:off x="8418424" y="2359152"/>
-            <a:ext cx="1606144" cy="566928"/>
-          </a:xfrm>
-          <a:prstGeom prst="rect">
-            <a:avLst/>
-          </a:prstGeom>
-          <a:noFill/>
-          <a:ln/>
-        </p:spPr>
-        <p:txBody>
-          <a:bodyPr wrap="square" lIns="0" tIns="0" rIns="0" bIns="0" rtlCol="0" anchor="t"/>
-          <a:lstStyle/>
-          <a:p>
-            <a:pPr indent="0" marL="0">
-              <a:buNone/>
-            </a:pPr>
-            <a:r>
-              <a:rPr lang="en-US" sz="1050" dirty="0">
-                <a:solidFill>
-                  <a:schemeClr val="tx2"/>
-                </a:solidFill>
-              </a:rPr>
-              <a:t>Coverage stays live while anchors report from the field.</a:t>
-            </a:r>
-            <a:endParaRPr lang="en-US" sz="1050" dirty="0"/>
-          </a:p>
-        </p:txBody>
-      </p:sp>
-      <p:sp>
-        <p:nvSpPr>
-          <p:cNvPr id="31" name="IMAGE SLOT - Anchor + AI double"/>
-          <p:cNvSpPr/>
-          <p:nvPr/>
-        </p:nvSpPr>
-        <p:spPr>
-          <a:xfrm>
-            <a:off x="10042855" y="1444752"/>
-            <a:ext cx="1600200" cy="1645920"/>
-          </a:xfrm>
-          <a:prstGeom prst="roundRect">
-            <a:avLst>
-              <a:gd name="adj" fmla="val 6857"/>
-            </a:avLst>
-          </a:prstGeom>
-          <a:solidFill>
-            <a:srgbClr val="E6E6EB"/>
-          </a:solidFill>
-          <a:ln/>
-        </p:spPr>
-      </p:sp>
       <p:pic>
         <p:nvPicPr>
-          <p:cNvPr id="32" name="slot icon - Anchor + AI double" descr="preencoded.png">    </p:cNvPr>
+          <p:cNvPr id="14" name="AI double image" descr="/tmp/claude-0/-home-user-nayak/e234e072-51fc-5a89-bcc1-7181d2d8a173/scratchpad/build/assets/u_double.png">    </p:cNvPr>
           <p:cNvPicPr>
             <a:picLocks noChangeAspect="1"/>
           </p:cNvPicPr>
@@ -2071,8 +1378,8 @@
         </p:blipFill>
         <p:spPr>
           <a:xfrm>
-            <a:off x="10696651" y="2011680"/>
-            <a:ext cx="292608" cy="292608"/>
+            <a:off x="9823399" y="1444752"/>
+            <a:ext cx="1819656" cy="1645920"/>
           </a:xfrm>
           <a:prstGeom prst="rect">
             <a:avLst/>
@@ -2081,43 +1388,91 @@
       </p:pic>
       <p:sp>
         <p:nvSpPr>
-          <p:cNvPr id="33" name="Text 28"/>
-          <p:cNvSpPr txBox="1"/>
-          <p:nvPr/>
-        </p:nvSpPr>
-        <p:spPr>
-          <a:xfrm>
-            <a:off x="10134295" y="2359152"/>
-            <a:ext cx="1417320" cy="201168"/>
-          </a:xfrm>
-          <a:prstGeom prst="rect">
-            <a:avLst/>
-          </a:prstGeom>
-          <a:noFill/>
-          <a:ln/>
-        </p:spPr>
-        <p:txBody>
-          <a:bodyPr wrap="square" lIns="0" tIns="0" rIns="0" bIns="0" rtlCol="0" anchor="t"/>
+          <p:cNvPr id="15" name="Label AI ANCHOR"/>
+          <p:cNvSpPr txBox="1"/>
+          <p:nvPr/>
+        </p:nvSpPr>
+        <p:spPr>
+          <a:xfrm>
+            <a:off x="7985455" y="2779776"/>
+            <a:ext cx="786384" cy="219456"/>
+          </a:xfrm>
+          <a:prstGeom prst="roundRect">
+            <a:avLst>
+              <a:gd name="adj" fmla="val 50000"/>
+            </a:avLst>
+          </a:prstGeom>
+          <a:solidFill>
+            <a:srgbClr val="FFFFFF">
+              <a:alpha val="92000"/>
+            </a:srgbClr>
+          </a:solidFill>
+          <a:ln/>
+        </p:spPr>
+        <p:txBody>
+          <a:bodyPr wrap="square" lIns="0" tIns="0" rIns="0" bIns="0" rtlCol="0" anchor="ctr"/>
           <a:lstStyle/>
           <a:p>
             <a:pPr algn="ctr" indent="0" marL="0">
               <a:buNone/>
             </a:pPr>
             <a:r>
-              <a:rPr lang="en-US" sz="850" dirty="0">
-                <a:solidFill>
-                  <a:schemeClr val="tx2"/>
-                </a:solidFill>
-              </a:rPr>
-              <a:t>Anchor + AI double</a:t>
-            </a:r>
-            <a:endParaRPr lang="en-US" sz="850" dirty="0"/>
-          </a:p>
-        </p:txBody>
-      </p:sp>
-      <p:sp>
-        <p:nvSpPr>
-          <p:cNvPr id="34" name="Tile - AI audio-visual studio"/>
+              <a:rPr lang="en-US" sz="800" b="1" dirty="0">
+                <a:solidFill>
+                  <a:schemeClr val="tx1"/>
+                </a:solidFill>
+              </a:rPr>
+              <a:t>AI ANCHOR</a:t>
+            </a:r>
+            <a:endParaRPr lang="en-US" sz="800" dirty="0"/>
+          </a:p>
+        </p:txBody>
+      </p:sp>
+      <p:sp>
+        <p:nvSpPr>
+          <p:cNvPr id="16" name="Label ANCHOR + AI DOUBLE"/>
+          <p:cNvSpPr txBox="1"/>
+          <p:nvPr/>
+        </p:nvSpPr>
+        <p:spPr>
+          <a:xfrm>
+            <a:off x="9933127" y="2779776"/>
+            <a:ext cx="1298448" cy="219456"/>
+          </a:xfrm>
+          <a:prstGeom prst="roundRect">
+            <a:avLst>
+              <a:gd name="adj" fmla="val 50000"/>
+            </a:avLst>
+          </a:prstGeom>
+          <a:solidFill>
+            <a:srgbClr val="FFFFFF">
+              <a:alpha val="92000"/>
+            </a:srgbClr>
+          </a:solidFill>
+          <a:ln/>
+        </p:spPr>
+        <p:txBody>
+          <a:bodyPr wrap="square" lIns="0" tIns="0" rIns="0" bIns="0" rtlCol="0" anchor="ctr"/>
+          <a:lstStyle/>
+          <a:p>
+            <a:pPr algn="ctr" indent="0" marL="0">
+              <a:buNone/>
+            </a:pPr>
+            <a:r>
+              <a:rPr lang="en-US" sz="800" b="1" dirty="0">
+                <a:solidFill>
+                  <a:schemeClr val="tx1"/>
+                </a:solidFill>
+              </a:rPr>
+              <a:t>ANCHOR + AI DOUBLE</a:t>
+            </a:r>
+            <a:endParaRPr lang="en-US" sz="800" dirty="0"/>
+          </a:p>
+        </p:txBody>
+      </p:sp>
+      <p:sp>
+        <p:nvSpPr>
+          <p:cNvPr id="17" name="Tile - AI studio"/>
           <p:cNvSpPr/>
           <p:nvPr/>
         </p:nvSpPr>
@@ -2139,14 +1494,14 @@
       </p:sp>
       <p:sp>
         <p:nvSpPr>
-          <p:cNvPr id="35" name="Text 30"/>
-          <p:cNvSpPr txBox="1"/>
-          <p:nvPr/>
-        </p:nvSpPr>
-        <p:spPr>
-          <a:xfrm>
-            <a:off x="4608576" y="3694176"/>
-            <a:ext cx="2194560" cy="182880"/>
+          <p:cNvPr id="18" name="Text 13"/>
+          <p:cNvSpPr txBox="1"/>
+          <p:nvPr/>
+        </p:nvSpPr>
+        <p:spPr>
+          <a:xfrm>
+            <a:off x="4608576" y="3657600"/>
+            <a:ext cx="2645359" cy="329184"/>
           </a:xfrm>
           <a:prstGeom prst="rect">
             <a:avLst/>
@@ -2159,46 +1514,13 @@
           <a:lstStyle/>
           <a:p>
             <a:pPr indent="0" marL="0">
-              <a:buNone/>
-            </a:pPr>
-            <a:r>
-              <a:rPr lang="en-US" sz="900" b="1" spc="120" kern="0" dirty="0">
-                <a:solidFill>
-                  <a:schemeClr val="accent2"/>
-                </a:solidFill>
-              </a:rPr>
-              <a:t>CREATE</a:t>
-            </a:r>
-            <a:endParaRPr lang="en-US" sz="900" dirty="0"/>
-          </a:p>
-        </p:txBody>
-      </p:sp>
-      <p:sp>
-        <p:nvSpPr>
-          <p:cNvPr id="36" name="Text 31"/>
-          <p:cNvSpPr txBox="1"/>
-          <p:nvPr/>
-        </p:nvSpPr>
-        <p:spPr>
-          <a:xfrm>
-            <a:off x="4608576" y="3950208"/>
-            <a:ext cx="2645359" cy="292608"/>
-          </a:xfrm>
-          <a:prstGeom prst="rect">
-            <a:avLst/>
-          </a:prstGeom>
-          <a:noFill/>
-          <a:ln/>
-        </p:spPr>
-        <p:txBody>
-          <a:bodyPr wrap="square" lIns="0" tIns="0" rIns="0" bIns="0" rtlCol="0" anchor="t"/>
-          <a:lstStyle/>
-          <a:p>
-            <a:pPr indent="0" marL="0">
-              <a:buNone/>
-            </a:pPr>
-            <a:r>
-              <a:rPr lang="en-US" sz="1500" b="1" dirty="0">
+              <a:lnSpc>
+                <a:spcPct val="95000"/>
+              </a:lnSpc>
+              <a:buNone/>
+            </a:pPr>
+            <a:r>
+              <a:rPr lang="en-US" sz="1600" b="1" dirty="0">
                 <a:solidFill>
                   <a:schemeClr val="tx1"/>
                 </a:solidFill>
@@ -2206,22 +1528,22 @@
                 <a:ea typeface="Georgia" pitchFamily="34" charset="-122"/>
                 <a:cs typeface="Georgia" pitchFamily="34" charset="-120"/>
               </a:rPr>
-              <a:t>AI audio-visual production</a:t>
-            </a:r>
-            <a:endParaRPr lang="en-US" sz="1500" dirty="0"/>
-          </a:p>
-        </p:txBody>
-      </p:sp>
-      <p:sp>
-        <p:nvSpPr>
-          <p:cNvPr id="37" name="Text 32"/>
-          <p:cNvSpPr txBox="1"/>
-          <p:nvPr/>
-        </p:nvSpPr>
-        <p:spPr>
-          <a:xfrm>
-            <a:off x="4608576" y="4288536"/>
-            <a:ext cx="2645359" cy="384048"/>
+              <a:t>An in-house AI studio</a:t>
+            </a:r>
+            <a:endParaRPr lang="en-US" sz="1600" dirty="0"/>
+          </a:p>
+        </p:txBody>
+      </p:sp>
+      <p:sp>
+        <p:nvSpPr>
+          <p:cNvPr id="19" name="Text 14"/>
+          <p:cNvSpPr txBox="1"/>
+          <p:nvPr/>
+        </p:nvSpPr>
+        <p:spPr>
+          <a:xfrm>
+            <a:off x="4608576" y="4041648"/>
+            <a:ext cx="2700223" cy="621792"/>
           </a:xfrm>
           <a:prstGeom prst="rect">
             <a:avLst/>
@@ -2237,26 +1559,26 @@
               <a:buNone/>
             </a:pPr>
             <a:r>
-              <a:rPr lang="en-US" sz="1050" dirty="0">
+              <a:rPr lang="en-US" sz="1000" dirty="0">
                 <a:solidFill>
                   <a:schemeClr val="tx2"/>
                 </a:solidFill>
               </a:rPr>
-              <a:t>Made in-house for TV, digital and events, even our covers since 1975, revived.</a:t>
-            </a:r>
-            <a:endParaRPr lang="en-US" sz="1050" dirty="0"/>
-          </a:p>
-        </p:txBody>
-      </p:sp>
-      <p:sp>
-        <p:nvSpPr>
-          <p:cNvPr id="38" name="Chip Voiceovers"/>
-          <p:cNvSpPr txBox="1"/>
-          <p:nvPr/>
-        </p:nvSpPr>
-        <p:spPr>
-          <a:xfrm>
-            <a:off x="4608576" y="4745736"/>
+              <a:t>Voiceovers, video and graphics for TV, digital and live events, made at the speed of news. Even iconic India Today covers since 1975, brought back to life.</a:t>
+            </a:r>
+            <a:endParaRPr lang="en-US" sz="1000" dirty="0"/>
+          </a:p>
+        </p:txBody>
+      </p:sp>
+      <p:sp>
+        <p:nvSpPr>
+          <p:cNvPr id="20" name="Chip Voiceovers"/>
+          <p:cNvSpPr txBox="1"/>
+          <p:nvPr/>
+        </p:nvSpPr>
+        <p:spPr>
+          <a:xfrm>
+            <a:off x="4608576" y="4736592"/>
             <a:ext cx="676656" cy="256032"/>
           </a:xfrm>
           <a:prstGeom prst="roundRect">
@@ -2279,7 +1601,7 @@
             <a:r>
               <a:rPr lang="en-US" sz="850" dirty="0">
                 <a:solidFill>
-                  <a:srgbClr val="7A3BD0"/>
+                  <a:schemeClr val="accent2"/>
                 </a:solidFill>
               </a:rPr>
               <a:t>Voiceovers</a:t>
@@ -2290,14 +1612,14 @@
       </p:sp>
       <p:sp>
         <p:nvSpPr>
-          <p:cNvPr id="39" name="Chip Images"/>
-          <p:cNvSpPr txBox="1"/>
-          <p:nvPr/>
-        </p:nvSpPr>
-        <p:spPr>
-          <a:xfrm>
-            <a:off x="5340096" y="4745736"/>
-            <a:ext cx="512064" cy="256032"/>
+          <p:cNvPr id="21" name="Chip Video"/>
+          <p:cNvSpPr txBox="1"/>
+          <p:nvPr/>
+        </p:nvSpPr>
+        <p:spPr>
+          <a:xfrm>
+            <a:off x="5340096" y="4736592"/>
+            <a:ext cx="457200" cy="256032"/>
           </a:xfrm>
           <a:prstGeom prst="roundRect">
             <a:avLst>
@@ -2319,10 +1641,10 @@
             <a:r>
               <a:rPr lang="en-US" sz="850" dirty="0">
                 <a:solidFill>
-                  <a:srgbClr val="7A3BD0"/>
-                </a:solidFill>
-              </a:rPr>
-              <a:t>Images</a:t>
+                  <a:schemeClr val="accent2"/>
+                </a:solidFill>
+              </a:rPr>
+              <a:t>Video</a:t>
             </a:r>
             <a:endParaRPr lang="en-US" sz="850" dirty="0"/>
           </a:p>
@@ -2330,14 +1652,14 @@
       </p:sp>
       <p:sp>
         <p:nvSpPr>
-          <p:cNvPr id="40" name="Chip Video"/>
-          <p:cNvSpPr txBox="1"/>
-          <p:nvPr/>
-        </p:nvSpPr>
-        <p:spPr>
-          <a:xfrm>
-            <a:off x="5907024" y="4745736"/>
-            <a:ext cx="457200" cy="256032"/>
+          <p:cNvPr id="22" name="Chip Infographics"/>
+          <p:cNvSpPr txBox="1"/>
+          <p:nvPr/>
+        </p:nvSpPr>
+        <p:spPr>
+          <a:xfrm>
+            <a:off x="5852160" y="4736592"/>
+            <a:ext cx="768096" cy="256032"/>
           </a:xfrm>
           <a:prstGeom prst="roundRect">
             <a:avLst>
@@ -2359,10 +1681,10 @@
             <a:r>
               <a:rPr lang="en-US" sz="850" dirty="0">
                 <a:solidFill>
-                  <a:srgbClr val="7A3BD0"/>
-                </a:solidFill>
-              </a:rPr>
-              <a:t>Video</a:t>
+                  <a:schemeClr val="accent2"/>
+                </a:solidFill>
+              </a:rPr>
+              <a:t>Infographics</a:t>
             </a:r>
             <a:endParaRPr lang="en-US" sz="850" dirty="0"/>
           </a:p>
@@ -2370,14 +1692,14 @@
       </p:sp>
       <p:sp>
         <p:nvSpPr>
-          <p:cNvPr id="41" name="Chip Infographics"/>
-          <p:cNvSpPr txBox="1"/>
-          <p:nvPr/>
-        </p:nvSpPr>
-        <p:spPr>
-          <a:xfrm>
-            <a:off x="6419088" y="4745736"/>
-            <a:ext cx="768096" cy="256032"/>
+          <p:cNvPr id="23" name="Chip Magazine covers"/>
+          <p:cNvSpPr txBox="1"/>
+          <p:nvPr/>
+        </p:nvSpPr>
+        <p:spPr>
+          <a:xfrm>
+            <a:off x="4608576" y="5038344"/>
+            <a:ext cx="1005840" cy="256032"/>
           </a:xfrm>
           <a:prstGeom prst="roundRect">
             <a:avLst>
@@ -2399,10 +1721,10 @@
             <a:r>
               <a:rPr lang="en-US" sz="850" dirty="0">
                 <a:solidFill>
-                  <a:srgbClr val="7A3BD0"/>
-                </a:solidFill>
-              </a:rPr>
-              <a:t>Infographics</a:t>
+                  <a:schemeClr val="accent2"/>
+                </a:solidFill>
+              </a:rPr>
+              <a:t>Magazine covers</a:t>
             </a:r>
             <a:endParaRPr lang="en-US" sz="850" dirty="0"/>
           </a:p>
@@ -2410,14 +1732,14 @@
       </p:sp>
       <p:sp>
         <p:nvSpPr>
-          <p:cNvPr id="42" name="Chip Magazine covers"/>
-          <p:cNvSpPr txBox="1"/>
-          <p:nvPr/>
-        </p:nvSpPr>
-        <p:spPr>
-          <a:xfrm>
-            <a:off x="4608576" y="5047488"/>
-            <a:ext cx="1005840" cy="256032"/>
+          <p:cNvPr id="24" name="Chip Illustrations"/>
+          <p:cNvSpPr txBox="1"/>
+          <p:nvPr/>
+        </p:nvSpPr>
+        <p:spPr>
+          <a:xfrm>
+            <a:off x="5669280" y="5038344"/>
+            <a:ext cx="749808" cy="256032"/>
           </a:xfrm>
           <a:prstGeom prst="roundRect">
             <a:avLst>
@@ -2439,10 +1761,10 @@
             <a:r>
               <a:rPr lang="en-US" sz="850" dirty="0">
                 <a:solidFill>
-                  <a:srgbClr val="7A3BD0"/>
-                </a:solidFill>
-              </a:rPr>
-              <a:t>Magazine covers</a:t>
+                  <a:schemeClr val="accent2"/>
+                </a:solidFill>
+              </a:rPr>
+              <a:t>Illustrations</a:t>
             </a:r>
             <a:endParaRPr lang="en-US" sz="850" dirty="0"/>
           </a:p>
@@ -2450,14 +1772,14 @@
       </p:sp>
       <p:sp>
         <p:nvSpPr>
-          <p:cNvPr id="43" name="Chip Illustrations"/>
-          <p:cNvSpPr txBox="1"/>
-          <p:nvPr/>
-        </p:nvSpPr>
-        <p:spPr>
-          <a:xfrm>
-            <a:off x="5669280" y="5047488"/>
-            <a:ext cx="749808" cy="256032"/>
+          <p:cNvPr id="25" name="Chip Fashion shows"/>
+          <p:cNvSpPr txBox="1"/>
+          <p:nvPr/>
+        </p:nvSpPr>
+        <p:spPr>
+          <a:xfrm>
+            <a:off x="6473952" y="5038344"/>
+            <a:ext cx="841248" cy="256032"/>
           </a:xfrm>
           <a:prstGeom prst="roundRect">
             <a:avLst>
@@ -2479,10 +1801,10 @@
             <a:r>
               <a:rPr lang="en-US" sz="850" dirty="0">
                 <a:solidFill>
-                  <a:srgbClr val="7A3BD0"/>
-                </a:solidFill>
-              </a:rPr>
-              <a:t>Illustrations</a:t>
+                  <a:schemeClr val="accent2"/>
+                </a:solidFill>
+              </a:rPr>
+              <a:t>Fashion shows</a:t>
             </a:r>
             <a:endParaRPr lang="en-US" sz="850" dirty="0"/>
           </a:p>
@@ -2490,54 +1812,14 @@
       </p:sp>
       <p:sp>
         <p:nvSpPr>
-          <p:cNvPr id="44" name="Chip Fashion shows"/>
-          <p:cNvSpPr txBox="1"/>
-          <p:nvPr/>
-        </p:nvSpPr>
-        <p:spPr>
-          <a:xfrm>
-            <a:off x="6473952" y="5047488"/>
-            <a:ext cx="841248" cy="256032"/>
-          </a:xfrm>
-          <a:prstGeom prst="roundRect">
-            <a:avLst>
-              <a:gd name="adj" fmla="val 50000"/>
-            </a:avLst>
-          </a:prstGeom>
-          <a:solidFill>
-            <a:srgbClr val="F1EBFB"/>
-          </a:solidFill>
-          <a:ln/>
-        </p:spPr>
-        <p:txBody>
-          <a:bodyPr wrap="square" lIns="0" tIns="0" rIns="0" bIns="0" rtlCol="0" anchor="ctr"/>
-          <a:lstStyle/>
-          <a:p>
-            <a:pPr algn="ctr" indent="0" marL="0">
-              <a:buNone/>
-            </a:pPr>
-            <a:r>
-              <a:rPr lang="en-US" sz="850" dirty="0">
-                <a:solidFill>
-                  <a:srgbClr val="7A3BD0"/>
-                </a:solidFill>
-              </a:rPr>
-              <a:t>Fashion shows</a:t>
-            </a:r>
-            <a:endParaRPr lang="en-US" sz="850" dirty="0"/>
-          </a:p>
-        </p:txBody>
-      </p:sp>
-      <p:sp>
-        <p:nvSpPr>
-          <p:cNvPr id="45" name="Tile - Operation Sindoor"/>
+          <p:cNvPr id="26" name="Tile - landmark AI stories"/>
           <p:cNvSpPr/>
           <p:nvPr/>
         </p:nvSpPr>
         <p:spPr>
           <a:xfrm>
             <a:off x="7656271" y="3419856"/>
-            <a:ext cx="2011680" cy="2011680"/>
+            <a:ext cx="4169664" cy="2011680"/>
           </a:xfrm>
           <a:prstGeom prst="roundRect">
             <a:avLst>
@@ -2552,29 +1834,49 @@
       </p:sp>
       <p:sp>
         <p:nvSpPr>
-          <p:cNvPr id="46" name="IMAGE SLOT - Film still"/>
-          <p:cNvSpPr/>
-          <p:nvPr/>
-        </p:nvSpPr>
-        <p:spPr>
-          <a:xfrm>
-            <a:off x="7802575" y="3566160"/>
-            <a:ext cx="1719072" cy="786384"/>
-          </a:xfrm>
-          <a:prstGeom prst="roundRect">
-            <a:avLst>
-              <a:gd name="adj" fmla="val 13953"/>
-            </a:avLst>
-          </a:prstGeom>
-          <a:solidFill>
-            <a:srgbClr val="E6E6EB"/>
-          </a:solidFill>
-          <a:ln/>
-        </p:spPr>
+          <p:cNvPr id="27" name="Text 22"/>
+          <p:cNvSpPr txBox="1"/>
+          <p:nvPr/>
+        </p:nvSpPr>
+        <p:spPr>
+          <a:xfrm>
+            <a:off x="7839151" y="3602736"/>
+            <a:ext cx="3803904" cy="310896"/>
+          </a:xfrm>
+          <a:prstGeom prst="rect">
+            <a:avLst/>
+          </a:prstGeom>
+          <a:noFill/>
+          <a:ln/>
+        </p:spPr>
+        <p:txBody>
+          <a:bodyPr wrap="square" lIns="0" tIns="0" rIns="0" bIns="0" rtlCol="0" anchor="t"/>
+          <a:lstStyle/>
+          <a:p>
+            <a:pPr indent="0" marL="0">
+              <a:lnSpc>
+                <a:spcPct val="95000"/>
+              </a:lnSpc>
+              <a:buNone/>
+            </a:pPr>
+            <a:r>
+              <a:rPr lang="en-US" sz="1600" b="1" dirty="0">
+                <a:solidFill>
+                  <a:schemeClr val="tx1"/>
+                </a:solidFill>
+                <a:latin typeface="Georgia" pitchFamily="34" charset="0"/>
+                <a:ea typeface="Georgia" pitchFamily="34" charset="-122"/>
+                <a:cs typeface="Georgia" pitchFamily="34" charset="-120"/>
+              </a:rPr>
+              <a:t>Stories only AI could tell</a:t>
+            </a:r>
+            <a:endParaRPr lang="en-US" sz="1600" dirty="0"/>
+          </a:p>
+        </p:txBody>
       </p:sp>
       <p:pic>
         <p:nvPicPr>
-          <p:cNvPr id="47" name="slot icon - Film still" descr="preencoded.png">    </p:cNvPr>
+          <p:cNvPr id="28" name="Operation Sindoor image" descr="/tmp/claude-0/-home-user-nayak/e234e072-51fc-5a89-bcc1-7181d2d8a173/scratchpad/build/assets/u_sindoor.png">    </p:cNvPr>
           <p:cNvPicPr>
             <a:picLocks noChangeAspect="1"/>
           </p:cNvPicPr>
@@ -2588,8 +1890,8 @@
         </p:blipFill>
         <p:spPr>
           <a:xfrm>
-            <a:off x="8544154" y="3731666"/>
-            <a:ext cx="235915" cy="235915"/>
+            <a:off x="7839151" y="3968496"/>
+            <a:ext cx="1828800" cy="731520"/>
           </a:xfrm>
           <a:prstGeom prst="rect">
             <a:avLst/>
@@ -2598,86 +1900,14 @@
       </p:pic>
       <p:sp>
         <p:nvSpPr>
-          <p:cNvPr id="48" name="Text 42"/>
-          <p:cNvSpPr txBox="1"/>
-          <p:nvPr/>
-        </p:nvSpPr>
-        <p:spPr>
-          <a:xfrm>
-            <a:off x="7894015" y="4050792"/>
-            <a:ext cx="1536192" cy="201168"/>
-          </a:xfrm>
-          <a:prstGeom prst="rect">
-            <a:avLst/>
-          </a:prstGeom>
-          <a:noFill/>
-          <a:ln/>
-        </p:spPr>
-        <p:txBody>
-          <a:bodyPr wrap="square" lIns="0" tIns="0" rIns="0" bIns="0" rtlCol="0" anchor="t"/>
-          <a:lstStyle/>
-          <a:p>
-            <a:pPr algn="ctr" indent="0" marL="0">
-              <a:buNone/>
-            </a:pPr>
-            <a:r>
-              <a:rPr lang="en-US" sz="850" dirty="0">
-                <a:solidFill>
-                  <a:schemeClr val="tx2"/>
-                </a:solidFill>
-              </a:rPr>
-              <a:t>Film still</a:t>
-            </a:r>
-            <a:endParaRPr lang="en-US" sz="850" dirty="0"/>
-          </a:p>
-        </p:txBody>
-      </p:sp>
-      <p:sp>
-        <p:nvSpPr>
-          <p:cNvPr id="49" name="Text 43"/>
-          <p:cNvSpPr txBox="1"/>
-          <p:nvPr/>
-        </p:nvSpPr>
-        <p:spPr>
-          <a:xfrm>
-            <a:off x="7839151" y="4443984"/>
-            <a:ext cx="1645920" cy="182880"/>
-          </a:xfrm>
-          <a:prstGeom prst="rect">
-            <a:avLst/>
-          </a:prstGeom>
-          <a:noFill/>
-          <a:ln/>
-        </p:spPr>
-        <p:txBody>
-          <a:bodyPr wrap="square" lIns="0" tIns="0" rIns="0" bIns="0" rtlCol="0" anchor="t"/>
-          <a:lstStyle/>
-          <a:p>
-            <a:pPr indent="0" marL="0">
-              <a:buNone/>
-            </a:pPr>
-            <a:r>
-              <a:rPr lang="en-US" sz="900" b="1" spc="120" kern="0" dirty="0">
-                <a:solidFill>
-                  <a:schemeClr val="accent3"/>
-                </a:solidFill>
-              </a:rPr>
-              <a:t>LANDMARK STORY</a:t>
-            </a:r>
-            <a:endParaRPr lang="en-US" sz="900" dirty="0"/>
-          </a:p>
-        </p:txBody>
-      </p:sp>
-      <p:sp>
-        <p:nvSpPr>
-          <p:cNvPr id="50" name="Text 44"/>
-          <p:cNvSpPr txBox="1"/>
-          <p:nvPr/>
-        </p:nvSpPr>
-        <p:spPr>
-          <a:xfrm>
-            <a:off x="7839151" y="4645152"/>
-            <a:ext cx="1645920" cy="384048"/>
+          <p:cNvPr id="29" name="Text 23"/>
+          <p:cNvSpPr txBox="1"/>
+          <p:nvPr/>
+        </p:nvSpPr>
+        <p:spPr>
+          <a:xfrm>
+            <a:off x="7839151" y="4773168"/>
+            <a:ext cx="1828800" cy="219456"/>
           </a:xfrm>
           <a:prstGeom prst="rect">
             <a:avLst/>
@@ -2696,7 +1926,7 @@
               <a:buNone/>
             </a:pPr>
             <a:r>
-              <a:rPr lang="en-US" sz="1250" b="1" dirty="0">
+              <a:rPr lang="en-US" sz="1150" b="1" dirty="0">
                 <a:solidFill>
                   <a:schemeClr val="tx1"/>
                 </a:solidFill>
@@ -2704,22 +1934,22 @@
                 <a:ea typeface="Georgia" pitchFamily="34" charset="-122"/>
                 <a:cs typeface="Georgia" pitchFamily="34" charset="-120"/>
               </a:rPr>
-              <a:t>Operation Sindoor, fully AI-made</a:t>
-            </a:r>
-            <a:endParaRPr lang="en-US" sz="1250" dirty="0"/>
-          </a:p>
-        </p:txBody>
-      </p:sp>
-      <p:sp>
-        <p:nvSpPr>
-          <p:cNvPr id="51" name="Text 45"/>
-          <p:cNvSpPr txBox="1"/>
-          <p:nvPr/>
-        </p:nvSpPr>
-        <p:spPr>
-          <a:xfrm>
-            <a:off x="7839151" y="5065776"/>
-            <a:ext cx="1645920" cy="292608"/>
+              <a:t>Operation Sindoor</a:t>
+            </a:r>
+            <a:endParaRPr lang="en-US" sz="1150" dirty="0"/>
+          </a:p>
+        </p:txBody>
+      </p:sp>
+      <p:sp>
+        <p:nvSpPr>
+          <p:cNvPr id="30" name="Text 24"/>
+          <p:cNvSpPr txBox="1"/>
+          <p:nvPr/>
+        </p:nvSpPr>
+        <p:spPr>
+          <a:xfrm>
+            <a:off x="7839151" y="4992624"/>
+            <a:ext cx="1828800" cy="402336"/>
           </a:xfrm>
           <a:prstGeom prst="rect">
             <a:avLst/>
@@ -2740,7 +1970,7 @@
                   <a:schemeClr val="tx2"/>
                 </a:solidFill>
               </a:rPr>
-              <a:t>First in Indian news media,</a:t>
+              <a:t>The first fully AI-made film</a:t>
             </a:r>
             <a:endParaRPr lang="en-US" sz="900" dirty="0"/>
           </a:p>
@@ -2754,59 +1984,15 @@
                   <a:schemeClr val="tx2"/>
                 </a:solidFill>
               </a:rPr>
-              <a:t>May 2025</a:t>
+              <a:t>in Indian news media, May 2025.</a:t>
             </a:r>
             <a:endParaRPr lang="en-US" sz="900" dirty="0"/>
           </a:p>
         </p:txBody>
-      </p:sp>
-      <p:sp>
-        <p:nvSpPr>
-          <p:cNvPr id="52" name="Tile - National anthem"/>
-          <p:cNvSpPr/>
-          <p:nvPr/>
-        </p:nvSpPr>
-        <p:spPr>
-          <a:xfrm>
-            <a:off x="9814255" y="3419856"/>
-            <a:ext cx="2011680" cy="2011680"/>
-          </a:xfrm>
-          <a:prstGeom prst="roundRect">
-            <a:avLst>
-              <a:gd name="adj" fmla="val 9091"/>
-            </a:avLst>
-          </a:prstGeom>
-          <a:solidFill>
-            <a:srgbClr val="FFFFFF"/>
-          </a:solidFill>
-          <a:ln/>
-        </p:spPr>
-      </p:sp>
-      <p:sp>
-        <p:nvSpPr>
-          <p:cNvPr id="53" name="IMAGE SLOT - Anthem still"/>
-          <p:cNvSpPr/>
-          <p:nvPr/>
-        </p:nvSpPr>
-        <p:spPr>
-          <a:xfrm>
-            <a:off x="9960559" y="3566160"/>
-            <a:ext cx="1719072" cy="786384"/>
-          </a:xfrm>
-          <a:prstGeom prst="roundRect">
-            <a:avLst>
-              <a:gd name="adj" fmla="val 13953"/>
-            </a:avLst>
-          </a:prstGeom>
-          <a:solidFill>
-            <a:srgbClr val="E6E6EB"/>
-          </a:solidFill>
-          <a:ln/>
-        </p:spPr>
       </p:sp>
       <p:pic>
         <p:nvPicPr>
-          <p:cNvPr id="54" name="slot icon - Anthem still" descr="preencoded.png">    </p:cNvPr>
+          <p:cNvPr id="31" name="The national anthem image" descr="/tmp/claude-0/-home-user-nayak/e234e072-51fc-5a89-bcc1-7181d2d8a173/scratchpad/build/assets/u_anthem.png">    </p:cNvPr>
           <p:cNvPicPr>
             <a:picLocks noChangeAspect="1"/>
           </p:cNvPicPr>
@@ -2820,8 +2006,8 @@
         </p:blipFill>
         <p:spPr>
           <a:xfrm>
-            <a:off x="10702138" y="3731666"/>
-            <a:ext cx="235915" cy="235915"/>
+            <a:off x="9814255" y="3968496"/>
+            <a:ext cx="1828800" cy="731520"/>
           </a:xfrm>
           <a:prstGeom prst="rect">
             <a:avLst/>
@@ -2830,86 +2016,14 @@
       </p:pic>
       <p:sp>
         <p:nvSpPr>
-          <p:cNvPr id="55" name="Text 48"/>
-          <p:cNvSpPr txBox="1"/>
-          <p:nvPr/>
-        </p:nvSpPr>
-        <p:spPr>
-          <a:xfrm>
-            <a:off x="10051999" y="4050792"/>
-            <a:ext cx="1536192" cy="201168"/>
-          </a:xfrm>
-          <a:prstGeom prst="rect">
-            <a:avLst/>
-          </a:prstGeom>
-          <a:noFill/>
-          <a:ln/>
-        </p:spPr>
-        <p:txBody>
-          <a:bodyPr wrap="square" lIns="0" tIns="0" rIns="0" bIns="0" rtlCol="0" anchor="t"/>
-          <a:lstStyle/>
-          <a:p>
-            <a:pPr algn="ctr" indent="0" marL="0">
-              <a:buNone/>
-            </a:pPr>
-            <a:r>
-              <a:rPr lang="en-US" sz="850" dirty="0">
-                <a:solidFill>
-                  <a:schemeClr val="tx2"/>
-                </a:solidFill>
-              </a:rPr>
-              <a:t>Anthem still</a:t>
-            </a:r>
-            <a:endParaRPr lang="en-US" sz="850" dirty="0"/>
-          </a:p>
-        </p:txBody>
-      </p:sp>
-      <p:sp>
-        <p:nvSpPr>
-          <p:cNvPr id="56" name="Text 49"/>
-          <p:cNvSpPr txBox="1"/>
-          <p:nvPr/>
-        </p:nvSpPr>
-        <p:spPr>
-          <a:xfrm>
-            <a:off x="9997135" y="4443984"/>
-            <a:ext cx="1645920" cy="182880"/>
-          </a:xfrm>
-          <a:prstGeom prst="rect">
-            <a:avLst/>
-          </a:prstGeom>
-          <a:noFill/>
-          <a:ln/>
-        </p:spPr>
-        <p:txBody>
-          <a:bodyPr wrap="square" lIns="0" tIns="0" rIns="0" bIns="0" rtlCol="0" anchor="t"/>
-          <a:lstStyle/>
-          <a:p>
-            <a:pPr indent="0" marL="0">
-              <a:buNone/>
-            </a:pPr>
-            <a:r>
-              <a:rPr lang="en-US" sz="900" b="1" spc="120" kern="0" dirty="0">
-                <a:solidFill>
-                  <a:schemeClr val="accent3"/>
-                </a:solidFill>
-              </a:rPr>
-              <a:t>LANDMARK STORY</a:t>
-            </a:r>
-            <a:endParaRPr lang="en-US" sz="900" dirty="0"/>
-          </a:p>
-        </p:txBody>
-      </p:sp>
-      <p:sp>
-        <p:nvSpPr>
-          <p:cNvPr id="57" name="Text 50"/>
-          <p:cNvSpPr txBox="1"/>
-          <p:nvPr/>
-        </p:nvSpPr>
-        <p:spPr>
-          <a:xfrm>
-            <a:off x="9997135" y="4645152"/>
-            <a:ext cx="1645920" cy="384048"/>
+          <p:cNvPr id="32" name="Text 25"/>
+          <p:cNvSpPr txBox="1"/>
+          <p:nvPr/>
+        </p:nvSpPr>
+        <p:spPr>
+          <a:xfrm>
+            <a:off x="9814255" y="4773168"/>
+            <a:ext cx="1828800" cy="219456"/>
           </a:xfrm>
           <a:prstGeom prst="rect">
             <a:avLst/>
@@ -2928,7 +2042,7 @@
               <a:buNone/>
             </a:pPr>
             <a:r>
-              <a:rPr lang="en-US" sz="1250" b="1" dirty="0">
+              <a:rPr lang="en-US" sz="1150" b="1" dirty="0">
                 <a:solidFill>
                   <a:schemeClr val="tx1"/>
                 </a:solidFill>
@@ -2936,22 +2050,22 @@
                 <a:ea typeface="Georgia" pitchFamily="34" charset="-122"/>
                 <a:cs typeface="Georgia" pitchFamily="34" charset="-120"/>
               </a:rPr>
-              <a:t>National anthem, recreated with AI</a:t>
-            </a:r>
-            <a:endParaRPr lang="en-US" sz="1250" dirty="0"/>
-          </a:p>
-        </p:txBody>
-      </p:sp>
-      <p:sp>
-        <p:nvSpPr>
-          <p:cNvPr id="58" name="Text 51"/>
-          <p:cNvSpPr txBox="1"/>
-          <p:nvPr/>
-        </p:nvSpPr>
-        <p:spPr>
-          <a:xfrm>
-            <a:off x="9997135" y="5065776"/>
-            <a:ext cx="1645920" cy="292608"/>
+              <a:t>The national anthem</a:t>
+            </a:r>
+            <a:endParaRPr lang="en-US" sz="1150" dirty="0"/>
+          </a:p>
+        </p:txBody>
+      </p:sp>
+      <p:sp>
+        <p:nvSpPr>
+          <p:cNvPr id="33" name="Text 26"/>
+          <p:cNvSpPr txBox="1"/>
+          <p:nvPr/>
+        </p:nvSpPr>
+        <p:spPr>
+          <a:xfrm>
+            <a:off x="9814255" y="4992624"/>
+            <a:ext cx="1828800" cy="402336"/>
           </a:xfrm>
           <a:prstGeom prst="rect">
             <a:avLst/>
@@ -2972,7 +2086,7 @@
                   <a:schemeClr val="tx2"/>
                 </a:solidFill>
               </a:rPr>
-              <a:t>Freedom fighters, in their own likeness.</a:t>
+              <a:t>Sung by India's freedom fighters, recreated by AI.</a:t>
             </a:r>
             <a:endParaRPr lang="en-US" sz="900" dirty="0"/>
           </a:p>
@@ -2980,7 +2094,7 @@
       </p:sp>
       <p:sp>
         <p:nvSpPr>
-          <p:cNvPr id="59" name="Tile - AI CMS"/>
+          <p:cNvPr id="34" name="Tile - AI CMS"/>
           <p:cNvSpPr/>
           <p:nvPr/>
         </p:nvSpPr>
@@ -3002,7 +2116,7 @@
       </p:sp>
       <p:sp>
         <p:nvSpPr>
-          <p:cNvPr id="60" name="CMS disc"/>
+          <p:cNvPr id="35" name="CMS disc"/>
           <p:cNvSpPr/>
           <p:nvPr/>
         </p:nvSpPr>
@@ -3022,7 +2136,7 @@
       </p:sp>
       <p:pic>
         <p:nvPicPr>
-          <p:cNvPr id="61" name="CMS icon" descr="preencoded.png">    </p:cNvPr>
+          <p:cNvPr id="36" name="CMS icon" descr="preencoded.png">    </p:cNvPr>
           <p:cNvPicPr>
             <a:picLocks noChangeAspect="1"/>
           </p:cNvPicPr>
@@ -3046,14 +2160,14 @@
       </p:pic>
       <p:sp>
         <p:nvSpPr>
-          <p:cNvPr id="62" name="Text 54"/>
-          <p:cNvSpPr txBox="1"/>
-          <p:nvPr/>
-        </p:nvSpPr>
-        <p:spPr>
-          <a:xfrm>
-            <a:off x="1280160" y="5733288"/>
-            <a:ext cx="2194560" cy="182880"/>
+          <p:cNvPr id="37" name="Text 29"/>
+          <p:cNvSpPr txBox="1"/>
+          <p:nvPr/>
+        </p:nvSpPr>
+        <p:spPr>
+          <a:xfrm>
+            <a:off x="1280160" y="5760720"/>
+            <a:ext cx="1783080" cy="256032"/>
           </a:xfrm>
           <a:prstGeom prst="rect">
             <a:avLst/>
@@ -3066,42 +2180,9 @@
           <a:lstStyle/>
           <a:p>
             <a:pPr indent="0" marL="0">
-              <a:buNone/>
-            </a:pPr>
-            <a:r>
-              <a:rPr lang="en-US" sz="900" b="1" spc="120" kern="0" dirty="0">
-                <a:solidFill>
-                  <a:schemeClr val="accent4"/>
-                </a:solidFill>
-              </a:rPr>
-              <a:t>NEWSROOM OPS</a:t>
-            </a:r>
-            <a:endParaRPr lang="en-US" sz="900" dirty="0"/>
-          </a:p>
-        </p:txBody>
-      </p:sp>
-      <p:sp>
-        <p:nvSpPr>
-          <p:cNvPr id="63" name="Text 55"/>
-          <p:cNvSpPr txBox="1"/>
-          <p:nvPr/>
-        </p:nvSpPr>
-        <p:spPr>
-          <a:xfrm>
-            <a:off x="1280160" y="5925312"/>
-            <a:ext cx="1737360" cy="256032"/>
-          </a:xfrm>
-          <a:prstGeom prst="rect">
-            <a:avLst/>
-          </a:prstGeom>
-          <a:noFill/>
-          <a:ln/>
-        </p:spPr>
-        <p:txBody>
-          <a:bodyPr wrap="square" lIns="0" tIns="0" rIns="0" bIns="0" rtlCol="0" anchor="t"/>
-          <a:lstStyle/>
-          <a:p>
-            <a:pPr indent="0" marL="0">
+              <a:lnSpc>
+                <a:spcPct val="95000"/>
+              </a:lnSpc>
               <a:buNone/>
             </a:pPr>
             <a:r>
@@ -3121,14 +2202,14 @@
       </p:sp>
       <p:sp>
         <p:nvSpPr>
-          <p:cNvPr id="64" name="Text 56"/>
-          <p:cNvSpPr txBox="1"/>
-          <p:nvPr/>
-        </p:nvSpPr>
-        <p:spPr>
-          <a:xfrm>
-            <a:off x="1280160" y="6190488"/>
-            <a:ext cx="1737360" cy="219456"/>
+          <p:cNvPr id="38" name="Text 30"/>
+          <p:cNvSpPr txBox="1"/>
+          <p:nvPr/>
+        </p:nvSpPr>
+        <p:spPr>
+          <a:xfrm>
+            <a:off x="1280160" y="6053328"/>
+            <a:ext cx="1783080" cy="365760"/>
           </a:xfrm>
           <a:prstGeom prst="rect">
             <a:avLst/>
@@ -3149,7 +2230,7 @@
                   <a:schemeClr val="tx2"/>
                 </a:solidFill>
               </a:rPr>
-              <a:t>Faster creation and delivery.</a:t>
+              <a:t>Faster creation and delivery on every platform.</a:t>
             </a:r>
             <a:endParaRPr lang="en-US" sz="950" dirty="0"/>
           </a:p>
@@ -3157,7 +2238,7 @@
       </p:sp>
       <p:sp>
         <p:nvSpPr>
-          <p:cNvPr id="65" name="Tile - automation"/>
+          <p:cNvPr id="39" name="Tile - automation"/>
           <p:cNvSpPr/>
           <p:nvPr/>
         </p:nvSpPr>
@@ -3179,14 +2260,14 @@
       </p:sp>
       <p:sp>
         <p:nvSpPr>
-          <p:cNvPr id="66" name="Text 58"/>
-          <p:cNvSpPr txBox="1"/>
-          <p:nvPr/>
-        </p:nvSpPr>
-        <p:spPr>
-          <a:xfrm>
-            <a:off x="3602736" y="5733288"/>
-            <a:ext cx="2194560" cy="182880"/>
+          <p:cNvPr id="40" name="Text 32"/>
+          <p:cNvSpPr txBox="1"/>
+          <p:nvPr/>
+        </p:nvSpPr>
+        <p:spPr>
+          <a:xfrm>
+            <a:off x="3602736" y="5760720"/>
+            <a:ext cx="2743200" cy="256032"/>
           </a:xfrm>
           <a:prstGeom prst="rect">
             <a:avLst/>
@@ -3199,42 +2280,9 @@
           <a:lstStyle/>
           <a:p>
             <a:pPr indent="0" marL="0">
-              <a:buNone/>
-            </a:pPr>
-            <a:r>
-              <a:rPr lang="en-US" sz="900" b="1" spc="120" kern="0" dirty="0">
-                <a:solidFill>
-                  <a:schemeClr val="accent4"/>
-                </a:solidFill>
-              </a:rPr>
-              <a:t>NEWSROOM OPS</a:t>
-            </a:r>
-            <a:endParaRPr lang="en-US" sz="900" dirty="0"/>
-          </a:p>
-        </p:txBody>
-      </p:sp>
-      <p:sp>
-        <p:nvSpPr>
-          <p:cNvPr id="67" name="Text 59"/>
-          <p:cNvSpPr txBox="1"/>
-          <p:nvPr/>
-        </p:nvSpPr>
-        <p:spPr>
-          <a:xfrm>
-            <a:off x="3602736" y="5925312"/>
-            <a:ext cx="2651760" cy="256032"/>
-          </a:xfrm>
-          <a:prstGeom prst="rect">
-            <a:avLst/>
-          </a:prstGeom>
-          <a:noFill/>
-          <a:ln/>
-        </p:spPr>
-        <p:txBody>
-          <a:bodyPr wrap="square" lIns="0" tIns="0" rIns="0" bIns="0" rtlCol="0" anchor="t"/>
-          <a:lstStyle/>
-          <a:p>
-            <a:pPr indent="0" marL="0">
+              <a:lnSpc>
+                <a:spcPct val="95000"/>
+              </a:lnSpc>
               <a:buNone/>
             </a:pPr>
             <a:r>
@@ -3246,7 +2294,7 @@
                 <a:ea typeface="Georgia" pitchFamily="34" charset="-122"/>
                 <a:cs typeface="Georgia" pitchFamily="34" charset="-120"/>
               </a:rPr>
-              <a:t>Routine updates, automated</a:t>
+              <a:t>Routine updates, on autopilot</a:t>
             </a:r>
             <a:endParaRPr lang="en-US" sz="1350" dirty="0"/>
           </a:p>
@@ -3254,14 +2302,14 @@
       </p:sp>
       <p:sp>
         <p:nvSpPr>
-          <p:cNvPr id="68" name="Text 60"/>
-          <p:cNvSpPr txBox="1"/>
-          <p:nvPr/>
-        </p:nvSpPr>
-        <p:spPr>
-          <a:xfrm>
-            <a:off x="3602736" y="6190488"/>
-            <a:ext cx="2651760" cy="219456"/>
+          <p:cNvPr id="41" name="Text 33"/>
+          <p:cNvSpPr txBox="1"/>
+          <p:nvPr/>
+        </p:nvSpPr>
+        <p:spPr>
+          <a:xfrm>
+            <a:off x="3602736" y="6053328"/>
+            <a:ext cx="2606040" cy="365760"/>
           </a:xfrm>
           <a:prstGeom prst="rect">
             <a:avLst/>
@@ -3282,7 +2330,7 @@
                   <a:schemeClr val="tx2"/>
                 </a:solidFill>
               </a:rPr>
-              <a:t>Frees journalists for context and judgment.</a:t>
+              <a:t>AI handles the repetitive, so journalists can focus on context and judgment.</a:t>
             </a:r>
             <a:endParaRPr lang="en-US" sz="950" dirty="0"/>
           </a:p>
@@ -3290,7 +2338,7 @@
       </p:sp>
       <p:pic>
         <p:nvPicPr>
-          <p:cNvPr id="69" name="Weather icon" descr="preencoded.png">    </p:cNvPr>
+          <p:cNvPr id="42" name="Weather icon" descr="preencoded.png">    </p:cNvPr>
           <p:cNvPicPr>
             <a:picLocks noChangeAspect="1"/>
           </p:cNvPicPr>
@@ -3314,7 +2362,7 @@
       </p:pic>
       <p:sp>
         <p:nvSpPr>
-          <p:cNvPr id="70" name="Text 61"/>
+          <p:cNvPr id="43" name="Text 34"/>
           <p:cNvSpPr txBox="1"/>
           <p:nvPr/>
         </p:nvSpPr>
@@ -3350,7 +2398,7 @@
       </p:sp>
       <p:pic>
         <p:nvPicPr>
-          <p:cNvPr id="71" name="Air quality icon" descr="preencoded.png">    </p:cNvPr>
+          <p:cNvPr id="44" name="Air quality icon" descr="preencoded.png">    </p:cNvPr>
           <p:cNvPicPr>
             <a:picLocks noChangeAspect="1"/>
           </p:cNvPicPr>
@@ -3374,7 +2422,7 @@
       </p:pic>
       <p:sp>
         <p:nvSpPr>
-          <p:cNvPr id="72" name="Text 62"/>
+          <p:cNvPr id="45" name="Text 35"/>
           <p:cNvSpPr txBox="1"/>
           <p:nvPr/>
         </p:nvSpPr>
@@ -3424,7 +2472,7 @@
       </p:sp>
       <p:pic>
         <p:nvPicPr>
-          <p:cNvPr id="73" name="Fuel prices icon" descr="preencoded.png">    </p:cNvPr>
+          <p:cNvPr id="46" name="Fuel prices icon" descr="preencoded.png">    </p:cNvPr>
           <p:cNvPicPr>
             <a:picLocks noChangeAspect="1"/>
           </p:cNvPicPr>
@@ -3448,7 +2496,7 @@
       </p:pic>
       <p:sp>
         <p:nvSpPr>
-          <p:cNvPr id="74" name="Text 63"/>
+          <p:cNvPr id="47" name="Text 36"/>
           <p:cNvSpPr txBox="1"/>
           <p:nvPr/>
         </p:nvSpPr>
@@ -3498,7 +2546,7 @@
       </p:sp>
       <p:pic>
         <p:nvPicPr>
-          <p:cNvPr id="75" name="Commodity rates icon" descr="preencoded.png">    </p:cNvPr>
+          <p:cNvPr id="48" name="Commodity rates icon" descr="preencoded.png">    </p:cNvPr>
           <p:cNvPicPr>
             <a:picLocks noChangeAspect="1"/>
           </p:cNvPicPr>
@@ -3522,7 +2570,7 @@
       </p:pic>
       <p:sp>
         <p:nvSpPr>
-          <p:cNvPr id="76" name="Text 64"/>
+          <p:cNvPr id="49" name="Text 37"/>
           <p:cNvSpPr txBox="1"/>
           <p:nvPr/>
         </p:nvSpPr>
@@ -3572,7 +2620,7 @@
       </p:sp>
       <p:sp>
         <p:nvSpPr>
-          <p:cNvPr id="77" name="Tile - commitment"/>
+          <p:cNvPr id="50" name="Tile - commitment"/>
           <p:cNvSpPr/>
           <p:nvPr/>
         </p:nvSpPr>
@@ -3594,7 +2642,7 @@
       </p:sp>
       <p:sp>
         <p:nvSpPr>
-          <p:cNvPr id="78" name="Text 66"/>
+          <p:cNvPr id="51" name="Text 39"/>
           <p:cNvSpPr txBox="1"/>
           <p:nvPr/>
         </p:nvSpPr>
@@ -3614,6 +2662,9 @@
           <a:lstStyle/>
           <a:p>
             <a:pPr indent="0" marL="0">
+              <a:lnSpc>
+                <a:spcPct val="95000"/>
+              </a:lnSpc>
               <a:buNone/>
             </a:pPr>
             <a:r>
@@ -3625,7 +2676,7 @@
                 <a:ea typeface="Georgia" pitchFamily="34" charset="-122"/>
                 <a:cs typeface="Georgia" pitchFamily="34" charset="-120"/>
               </a:rPr>
-              <a:t>Truth and credibility at the heart of it.</a:t>
+              <a:t>Truth and credibility stay at the heart of it.</a:t>
             </a:r>
             <a:endParaRPr lang="en-US" sz="1250" dirty="0"/>
           </a:p>
@@ -3633,14 +2684,14 @@
       </p:sp>
       <p:sp>
         <p:nvSpPr>
-          <p:cNvPr id="79" name="Text 67"/>
+          <p:cNvPr id="52" name="Text 40"/>
           <p:cNvSpPr txBox="1"/>
           <p:nvPr/>
         </p:nvSpPr>
         <p:spPr>
           <a:xfrm>
             <a:off x="9155887" y="6181344"/>
-            <a:ext cx="2514600" cy="219456"/>
+            <a:ext cx="2560320" cy="219456"/>
           </a:xfrm>
           <a:prstGeom prst="rect">
             <a:avLst/>
@@ -3661,7 +2712,7 @@
                   <a:srgbClr val="C7C7CC"/>
                 </a:solidFill>
               </a:rPr>
-              <a:t>A 50-year legacy, gearing for the </a:t>
+              <a:t>A 50-year legacy, gearing up for the </a:t>
             </a:r>
             <a:pPr indent="0" marL="0">
               <a:buNone/>

</xml_diff>